<commit_message>
docs(review-1): refresh implementation progress
</commit_message>
<xml_diff>
--- a/deliverables/review-1/semantic-communication-first-review-academic-v2.pptx
+++ b/deliverables/review-1/semantic-communication-first-review-academic-v2.pptx
@@ -9291,7 +9291,7 @@
                 </a:solidFill>
                 <a:latin typeface="Cascadia Mono"/>
               </a:rPr>
-              <a:t>results/baseline/g8/campaign_state.json</a:t>
+              <a:t>results/baseline/g8_pascal_successor/successor_bler_table.json</a:t>
             </a:r>
           </a:p>
         </p:txBody>
@@ -9336,7 +9336,7 @@
                 </a:solidFill>
                 <a:latin typeface="Arial"/>
               </a:rPr>
-              <a:t>authenticated characterization cursor</a:t>
+              <a:t>153 measured-only curves; successor table frozen</a:t>
             </a:r>
           </a:p>
         </p:txBody>
@@ -9381,7 +9381,7 @@
                 </a:solidFill>
                 <a:latin typeface="Cascadia Mono"/>
               </a:rPr>
-              <a:t>Spec</a:t>
+              <a:t>G8_D</a:t>
             </a:r>
           </a:p>
         </p:txBody>
@@ -9426,7 +9426,7 @@
                 </a:solidFill>
                 <a:latin typeface="Cascadia Mono"/>
               </a:rPr>
-              <a:t>spec/SPEC.md</a:t>
+              <a:t>results/baseline/g8_d/d7_handoff.json</a:t>
             </a:r>
           </a:p>
         </p:txBody>
@@ -9471,7 +9471,7 @@
                 </a:solidFill>
                 <a:latin typeface="Arial"/>
               </a:rPr>
-              <a:t>normative hypotheses and requirements</a:t>
+              <a:t>D0–D7 GREEN; tooling ready; full campaign not started</a:t>
             </a:r>
           </a:p>
         </p:txBody>
@@ -9516,7 +9516,7 @@
                 </a:solidFill>
                 <a:latin typeface="Cascadia Mono"/>
               </a:rPr>
-              <a:t>Plan</a:t>
+              <a:t>Spec</a:t>
             </a:r>
           </a:p>
         </p:txBody>
@@ -9561,7 +9561,7 @@
                 </a:solidFill>
                 <a:latin typeface="Cascadia Mono"/>
               </a:rPr>
-              <a:t>docs/gantt-plan.md</a:t>
+              <a:t>spec/SPEC.md</a:t>
             </a:r>
           </a:p>
         </p:txBody>
@@ -9606,7 +9606,7 @@
                 </a:solidFill>
                 <a:latin typeface="Arial"/>
               </a:rPr>
-              <a:t>dates, gates and current status</a:t>
+              <a:t>normative hypotheses and requirements</a:t>
             </a:r>
           </a:p>
         </p:txBody>
@@ -9651,7 +9651,7 @@
                 </a:solidFill>
                 <a:latin typeface="Cascadia Mono"/>
               </a:rPr>
-              <a:t>Deploy</a:t>
+              <a:t>Plan</a:t>
             </a:r>
           </a:p>
         </p:txBody>
@@ -9696,7 +9696,7 @@
                 </a:solidFill>
                 <a:latin typeface="Cascadia Mono"/>
               </a:rPr>
-              <a:t>docs/deployment-dossier.md</a:t>
+              <a:t>docs/gantt-plan.md</a:t>
             </a:r>
           </a:p>
         </p:txBody>
@@ -9741,6 +9741,141 @@
                 </a:solidFill>
                 <a:latin typeface="Arial"/>
               </a:rPr>
+              <a:t>dates, gates and current status</a:t>
+            </a:r>
+          </a:p>
+        </p:txBody>
+      </p:sp>
+      <p:sp>
+        <p:nvSpPr>
+          <p:cNvPr id="46" name="TextBox 45"/>
+          <p:cNvSpPr txBox="1"/>
+          <p:nvPr/>
+        </p:nvSpPr>
+        <p:spPr>
+          <a:xfrm>
+            <a:off x="6400800" y="5916168"/>
+            <a:ext cx="566928" cy="182880"/>
+          </a:xfrm>
+          <a:prstGeom prst="rect">
+            <a:avLst/>
+          </a:prstGeom>
+          <a:noFill/>
+        </p:spPr>
+        <p:txBody>
+          <a:bodyPr wrap="square" lIns="45720" rIns="45720" anchor="t">
+            <a:spAutoFit/>
+          </a:bodyPr>
+          <a:lstStyle/>
+          <a:p>
+            <a:pPr algn="l">
+              <a:lnSpc>
+                <a:spcPct val="100000"/>
+              </a:lnSpc>
+              <a:spcBef>
+                <a:spcPts val="0"/>
+              </a:spcBef>
+              <a:spcAft>
+                <a:spcPts val="0"/>
+              </a:spcAft>
+            </a:pPr>
+            <a:r>
+              <a:rPr sz="819" b="1" i="0">
+                <a:solidFill>
+                  <a:srgbClr val="8A3346"/>
+                </a:solidFill>
+                <a:latin typeface="Cascadia Mono"/>
+              </a:rPr>
+              <a:t>Deploy</a:t>
+            </a:r>
+          </a:p>
+        </p:txBody>
+      </p:sp>
+      <p:sp>
+        <p:nvSpPr>
+          <p:cNvPr id="47" name="TextBox 46"/>
+          <p:cNvSpPr txBox="1"/>
+          <p:nvPr/>
+        </p:nvSpPr>
+        <p:spPr>
+          <a:xfrm>
+            <a:off x="7040880" y="5897880"/>
+            <a:ext cx="4160520" cy="182880"/>
+          </a:xfrm>
+          <a:prstGeom prst="rect">
+            <a:avLst/>
+          </a:prstGeom>
+          <a:noFill/>
+        </p:spPr>
+        <p:txBody>
+          <a:bodyPr wrap="square" lIns="45720" rIns="45720" anchor="t">
+            <a:spAutoFit/>
+          </a:bodyPr>
+          <a:lstStyle/>
+          <a:p>
+            <a:pPr algn="l">
+              <a:lnSpc>
+                <a:spcPct val="100000"/>
+              </a:lnSpc>
+              <a:spcBef>
+                <a:spcPts val="0"/>
+              </a:spcBef>
+              <a:spcAft>
+                <a:spcPts val="0"/>
+              </a:spcAft>
+            </a:pPr>
+            <a:r>
+              <a:rPr sz="720" b="0" i="0">
+                <a:solidFill>
+                  <a:srgbClr val="203A57"/>
+                </a:solidFill>
+                <a:latin typeface="Cascadia Mono"/>
+              </a:rPr>
+              <a:t>docs/deployment-dossier.md</a:t>
+            </a:r>
+          </a:p>
+        </p:txBody>
+      </p:sp>
+      <p:sp>
+        <p:nvSpPr>
+          <p:cNvPr id="48" name="TextBox 47"/>
+          <p:cNvSpPr txBox="1"/>
+          <p:nvPr/>
+        </p:nvSpPr>
+        <p:spPr>
+          <a:xfrm>
+            <a:off x="7040880" y="6126480"/>
+            <a:ext cx="4160520" cy="155448"/>
+          </a:xfrm>
+          <a:prstGeom prst="rect">
+            <a:avLst/>
+          </a:prstGeom>
+          <a:noFill/>
+        </p:spPr>
+        <p:txBody>
+          <a:bodyPr wrap="square" lIns="45720" rIns="45720" anchor="t">
+            <a:spAutoFit/>
+          </a:bodyPr>
+          <a:lstStyle/>
+          <a:p>
+            <a:pPr algn="l">
+              <a:lnSpc>
+                <a:spcPct val="100000"/>
+              </a:lnSpc>
+              <a:spcBef>
+                <a:spcPts val="0"/>
+              </a:spcBef>
+              <a:spcAft>
+                <a:spcPts val="0"/>
+              </a:spcAft>
+            </a:pPr>
+            <a:r>
+              <a:rPr sz="750" b="0" i="0">
+                <a:solidFill>
+                  <a:srgbClr val="5B6570"/>
+                </a:solidFill>
+                <a:latin typeface="Arial"/>
+              </a:rPr>
               <a:t>simulation-first + SDR stretch</a:t>
             </a:r>
           </a:p>
@@ -9748,7 +9883,7 @@
       </p:sp>
       <p:sp>
         <p:nvSpPr>
-          <p:cNvPr id="46" name="Rounded Rectangle 45"/>
+          <p:cNvPr id="49" name="Rounded Rectangle 48"/>
           <p:cNvSpPr/>
           <p:nvPr/>
         </p:nvSpPr>
@@ -9791,7 +9926,7 @@
       </p:sp>
       <p:sp>
         <p:nvSpPr>
-          <p:cNvPr id="47" name="TextBox 46"/>
+          <p:cNvPr id="50" name="TextBox 49"/>
           <p:cNvSpPr txBox="1"/>
           <p:nvPr/>
         </p:nvSpPr>
@@ -9829,14 +9964,14 @@
                 </a:solidFill>
                 <a:latin typeface="Arial"/>
               </a:rPr>
-              <a:t>Refresh G8_C status from instructions/RESUME.md on submission day.</a:t>
+              <a:t>Refresh G8_C/G8_D status from the handoff files on submission day.</a:t>
             </a:r>
           </a:p>
         </p:txBody>
       </p:sp>
       <p:cxnSp>
         <p:nvCxnSpPr>
-          <p:cNvPr id="48" name="Connector 47"/>
+          <p:cNvPr id="51" name="Connector 50"/>
           <p:cNvCxnSpPr/>
           <p:nvPr/>
         </p:nvCxnSpPr>
@@ -9871,7 +10006,7 @@
       </p:cxnSp>
       <p:sp>
         <p:nvSpPr>
-          <p:cNvPr id="49" name="Rounded Rectangle 48"/>
+          <p:cNvPr id="52" name="Rounded Rectangle 51"/>
           <p:cNvSpPr/>
           <p:nvPr/>
         </p:nvSpPr>
@@ -9914,7 +10049,7 @@
       </p:sp>
       <p:sp>
         <p:nvSpPr>
-          <p:cNvPr id="50" name="TextBox 49"/>
+          <p:cNvPr id="53" name="TextBox 52"/>
           <p:cNvSpPr txBox="1"/>
           <p:nvPr/>
         </p:nvSpPr>
@@ -9959,7 +10094,7 @@
       </p:sp>
       <p:sp>
         <p:nvSpPr>
-          <p:cNvPr id="51" name="Rounded Rectangle 50"/>
+          <p:cNvPr id="54" name="Rounded Rectangle 53"/>
           <p:cNvSpPr/>
           <p:nvPr/>
         </p:nvSpPr>
@@ -10002,7 +10137,7 @@
       </p:sp>
       <p:sp>
         <p:nvSpPr>
-          <p:cNvPr id="52" name="TextBox 51"/>
+          <p:cNvPr id="55" name="TextBox 54"/>
           <p:cNvSpPr txBox="1"/>
           <p:nvPr/>
         </p:nvSpPr>
@@ -10047,7 +10182,7 @@
       </p:sp>
       <p:sp>
         <p:nvSpPr>
-          <p:cNvPr id="53" name="TextBox 52"/>
+          <p:cNvPr id="56" name="TextBox 55"/>
           <p:cNvSpPr txBox="1"/>
           <p:nvPr/>
         </p:nvSpPr>
@@ -10092,7 +10227,7 @@
       </p:sp>
       <p:sp>
         <p:nvSpPr>
-          <p:cNvPr id="54" name="TextBox 53"/>
+          <p:cNvPr id="57" name="TextBox 56"/>
           <p:cNvSpPr txBox="1"/>
           <p:nvPr/>
         </p:nvSpPr>
@@ -22502,7 +22637,7 @@
                 </a:solidFill>
                 <a:latin typeface="Arial"/>
               </a:rPr>
-              <a:t>G8_C · CURRENT</a:t>
+              <a:t>G8_C · COMPLETE</a:t>
             </a:r>
           </a:p>
         </p:txBody>
@@ -22541,13 +22676,13 @@
               </a:spcAft>
             </a:pPr>
             <a:r>
-              <a:rPr sz="2000" b="1" i="0">
+              <a:rPr sz="1700" b="1" i="0">
                 <a:solidFill>
                   <a:srgbClr val="203A57"/>
                 </a:solidFill>
                 <a:latin typeface="Georgia"/>
               </a:rPr>
-              <a:t>C2 paused</a:t>
+              <a:t>COMPLETE</a:t>
             </a:r>
           </a:p>
         </p:txBody>
@@ -22586,23 +22721,23 @@
               </a:spcAft>
             </a:pPr>
             <a:r>
-              <a:rPr sz="1040" b="0" i="0">
+              <a:rPr sz="969" b="0" i="0">
                 <a:solidFill>
                   <a:srgbClr val="18212B"/>
                 </a:solidFill>
                 <a:latin typeface="Arial"/>
               </a:rPr>
-              <a:t>authenticated durable checkpoint</a:t>
+              <a:t>Pascal successor: 3,213/3,213 identities</a:t>
             </a:r>
             <a:br/>
             <a:r>
-              <a:rPr sz="1040" b="0" i="0">
+              <a:rPr sz="969" b="0" i="0">
                 <a:solidFill>
                   <a:srgbClr val="18212B"/>
                 </a:solidFill>
                 <a:latin typeface="Arial"/>
               </a:rPr>
-              <a:t>source epoch 2 registered · safely resumable</a:t>
+              <a:t>153 measured-only curves · successor table frozen</a:t>
             </a:r>
           </a:p>
         </p:txBody>
@@ -22641,23 +22776,23 @@
               </a:spcAft>
             </a:pPr>
             <a:r>
-              <a:rPr sz="980" b="1" i="0">
+              <a:rPr sz="900" b="1" i="0">
                 <a:solidFill>
                   <a:srgbClr val="8A3346"/>
                 </a:solidFill>
                 <a:latin typeface="Arial"/>
               </a:rPr>
-              <a:t>BLER table: not frozen</a:t>
+              <a:t>G8_D tooling: COMPLETE</a:t>
             </a:r>
             <a:br/>
             <a:r>
-              <a:rPr sz="980" b="1" i="0">
+              <a:rPr sz="900" b="1" i="0">
                 <a:solidFill>
                   <a:srgbClr val="8A3346"/>
                 </a:solidFill>
                 <a:latin typeface="Arial"/>
               </a:rPr>
-              <a:t>selection / inference / training / test: 0</a:t>
+              <a:t>G8_E/E0: PLANNED / NOT STARTED</a:t>
             </a:r>
           </a:p>
         </p:txBody>
@@ -22696,13 +22831,13 @@
               </a:spcAft>
             </a:pPr>
             <a:r>
-              <a:rPr sz="1010" b="0" i="1">
+              <a:rPr sz="940" b="0" i="1">
                 <a:solidFill>
                   <a:srgbClr val="5B6570"/>
                 </a:solidFill>
                 <a:latin typeface="Georgia"/>
               </a:rPr>
-              <a:t>Interpretation: the reference task, computational budget and digital chain are verified; the comparison itself remains ahead.</a:t>
+              <a:t>No full validation measurement/pass one, training/fine-tuning, learned-vs-classical result or test evaluation has occurred.</a:t>
             </a:r>
           </a:p>
         </p:txBody>
@@ -22870,7 +23005,7 @@
                 </a:solidFill>
                 <a:latin typeface="Arial"/>
               </a:rPr>
-              <a:t>Authenticated records: G-1, G-2, G-7, W4 and G8_C · test split access = 0</a:t>
+              <a:t>Authenticated records: G-1, G-2, G-7, W4, G8_C and G8_D · test split access = 0</a:t>
             </a:r>
           </a:p>
         </p:txBody>
@@ -23779,7 +23914,7 @@
                 </a:solidFill>
                 <a:latin typeface="Arial"/>
               </a:rPr>
-              <a:t>BLER characterization + G-8</a:t>
+              <a:t>G8_C BLER characterization</a:t>
             </a:r>
           </a:p>
         </p:txBody>
@@ -23792,7 +23927,7 @@
         </p:nvCxnSpPr>
         <p:spPr>
           <a:xfrm>
-            <a:off x="713232" y="2404872"/>
+            <a:off x="713232" y="2340864"/>
             <a:ext cx="10442448" cy="0"/>
           </a:xfrm>
           <a:prstGeom prst="line">
@@ -23828,7 +23963,1048 @@
         <p:spPr>
           <a:xfrm>
             <a:off x="3127248" y="2020824"/>
+            <a:ext cx="458767" cy="283464"/>
+          </a:xfrm>
+          <a:prstGeom prst="roundRect">
+            <a:avLst/>
+          </a:prstGeom>
+          <a:solidFill>
+            <a:srgbClr val="D9D9D9"/>
+          </a:solidFill>
+          <a:ln>
+            <a:noFill/>
+          </a:ln>
+        </p:spPr>
+        <p:style>
+          <a:lnRef idx="1">
+            <a:schemeClr val="accent1"/>
+          </a:lnRef>
+          <a:fillRef idx="3">
+            <a:schemeClr val="accent1"/>
+          </a:fillRef>
+          <a:effectRef idx="2">
+            <a:schemeClr val="accent1"/>
+          </a:effectRef>
+          <a:fontRef idx="minor">
+            <a:schemeClr val="lt1"/>
+          </a:fontRef>
+        </p:style>
+        <p:txBody>
+          <a:bodyPr rtlCol="0" anchor="ctr"/>
+          <a:lstStyle/>
+          <a:p>
+            <a:pPr algn="ctr"/>
+          </a:p>
+        </p:txBody>
+      </p:sp>
+      <p:sp>
+        <p:nvSpPr>
+          <p:cNvPr id="24" name="TextBox 23"/>
+          <p:cNvSpPr txBox="1"/>
+          <p:nvPr/>
+        </p:nvSpPr>
+        <p:spPr>
+          <a:xfrm>
+            <a:off x="731520" y="2432303"/>
+            <a:ext cx="2176272" cy="228600"/>
+          </a:xfrm>
+          <a:prstGeom prst="rect">
+            <a:avLst/>
+          </a:prstGeom>
+          <a:noFill/>
+        </p:spPr>
+        <p:txBody>
+          <a:bodyPr wrap="square" lIns="45720" rIns="45720" anchor="ctr">
+            <a:spAutoFit/>
+          </a:bodyPr>
+          <a:lstStyle/>
+          <a:p>
+            <a:pPr algn="l">
+              <a:lnSpc>
+                <a:spcPct val="100000"/>
+              </a:lnSpc>
+              <a:spcBef>
+                <a:spcPts val="0"/>
+              </a:spcBef>
+              <a:spcAft>
+                <a:spcPts val="0"/>
+              </a:spcAft>
+            </a:pPr>
+            <a:r>
+              <a:rPr sz="940" b="0" i="0">
+                <a:solidFill>
+                  <a:srgbClr val="18212B"/>
+                </a:solidFill>
+                <a:latin typeface="Arial"/>
+              </a:rPr>
+              <a:t>G8_D validation-measurement tooling</a:t>
+            </a:r>
+          </a:p>
+        </p:txBody>
+      </p:sp>
+      <p:cxnSp>
+        <p:nvCxnSpPr>
+          <p:cNvPr id="25" name="Connector 24"/>
+          <p:cNvCxnSpPr/>
+          <p:nvPr/>
+        </p:nvCxnSpPr>
+        <p:spPr>
+          <a:xfrm>
+            <a:off x="713232" y="2761488"/>
+            <a:ext cx="10442448" cy="0"/>
+          </a:xfrm>
+          <a:prstGeom prst="line">
+            <a:avLst/>
+          </a:prstGeom>
+          <a:ln w="4445">
+            <a:solidFill>
+              <a:srgbClr val="D7D2C8"/>
+            </a:solidFill>
+          </a:ln>
+        </p:spPr>
+        <p:style>
+          <a:lnRef idx="2">
+            <a:schemeClr val="accent1"/>
+          </a:lnRef>
+          <a:fillRef idx="0">
+            <a:schemeClr val="accent1"/>
+          </a:fillRef>
+          <a:effectRef idx="1">
+            <a:schemeClr val="accent1"/>
+          </a:effectRef>
+          <a:fontRef idx="minor">
+            <a:schemeClr val="tx1"/>
+          </a:fontRef>
+        </p:style>
+      </p:cxnSp>
+      <p:sp>
+        <p:nvSpPr>
+          <p:cNvPr id="26" name="Rounded Rectangle 25"/>
+          <p:cNvSpPr/>
+          <p:nvPr/>
+        </p:nvSpPr>
+        <p:spPr>
+          <a:xfrm>
+            <a:off x="3586015" y="2441448"/>
+            <a:ext cx="229383" cy="283464"/>
+          </a:xfrm>
+          <a:prstGeom prst="roundRect">
+            <a:avLst/>
+          </a:prstGeom>
+          <a:solidFill>
+            <a:srgbClr val="D9D9D9"/>
+          </a:solidFill>
+          <a:ln>
+            <a:noFill/>
+          </a:ln>
+        </p:spPr>
+        <p:style>
+          <a:lnRef idx="1">
+            <a:schemeClr val="accent1"/>
+          </a:lnRef>
+          <a:fillRef idx="3">
+            <a:schemeClr val="accent1"/>
+          </a:fillRef>
+          <a:effectRef idx="2">
+            <a:schemeClr val="accent1"/>
+          </a:effectRef>
+          <a:fontRef idx="minor">
+            <a:schemeClr val="lt1"/>
+          </a:fontRef>
+        </p:style>
+        <p:txBody>
+          <a:bodyPr rtlCol="0" anchor="ctr"/>
+          <a:lstStyle/>
+          <a:p>
+            <a:pPr algn="ctr"/>
+          </a:p>
+        </p:txBody>
+      </p:sp>
+      <p:sp>
+        <p:nvSpPr>
+          <p:cNvPr id="27" name="TextBox 26"/>
+          <p:cNvSpPr txBox="1"/>
+          <p:nvPr/>
+        </p:nvSpPr>
+        <p:spPr>
+          <a:xfrm>
+            <a:off x="731520" y="2852927"/>
+            <a:ext cx="2176272" cy="228600"/>
+          </a:xfrm>
+          <a:prstGeom prst="rect">
+            <a:avLst/>
+          </a:prstGeom>
+          <a:noFill/>
+        </p:spPr>
+        <p:txBody>
+          <a:bodyPr wrap="square" lIns="45720" rIns="45720" anchor="ctr">
+            <a:spAutoFit/>
+          </a:bodyPr>
+          <a:lstStyle/>
+          <a:p>
+            <a:pPr algn="l">
+              <a:lnSpc>
+                <a:spcPct val="100000"/>
+              </a:lnSpc>
+              <a:spcBef>
+                <a:spcPts val="0"/>
+              </a:spcBef>
+              <a:spcAft>
+                <a:spcPts val="0"/>
+              </a:spcAft>
+            </a:pPr>
+            <a:r>
+              <a:rPr sz="940" b="0" i="0">
+                <a:solidFill>
+                  <a:srgbClr val="18212B"/>
+                </a:solidFill>
+                <a:latin typeface="Arial"/>
+              </a:rPr>
+              <a:t>G8_E validation + pass one / G-8</a:t>
+            </a:r>
+          </a:p>
+        </p:txBody>
+      </p:sp>
+      <p:cxnSp>
+        <p:nvCxnSpPr>
+          <p:cNvPr id="28" name="Connector 27"/>
+          <p:cNvCxnSpPr/>
+          <p:nvPr/>
+        </p:nvCxnSpPr>
+        <p:spPr>
+          <a:xfrm>
+            <a:off x="713232" y="3182112"/>
+            <a:ext cx="10442448" cy="0"/>
+          </a:xfrm>
+          <a:prstGeom prst="line">
+            <a:avLst/>
+          </a:prstGeom>
+          <a:ln w="4445">
+            <a:solidFill>
+              <a:srgbClr val="D7D2C8"/>
+            </a:solidFill>
+          </a:ln>
+        </p:spPr>
+        <p:style>
+          <a:lnRef idx="2">
+            <a:schemeClr val="accent1"/>
+          </a:lnRef>
+          <a:fillRef idx="0">
+            <a:schemeClr val="accent1"/>
+          </a:fillRef>
+          <a:effectRef idx="1">
+            <a:schemeClr val="accent1"/>
+          </a:effectRef>
+          <a:fontRef idx="minor">
+            <a:schemeClr val="tx1"/>
+          </a:fontRef>
+        </p:style>
+      </p:cxnSp>
+      <p:sp>
+        <p:nvSpPr>
+          <p:cNvPr id="29" name="Rounded Rectangle 28"/>
+          <p:cNvSpPr/>
+          <p:nvPr/>
+        </p:nvSpPr>
+        <p:spPr>
+          <a:xfrm>
+            <a:off x="3815399" y="2862072"/>
+            <a:ext cx="382306" cy="283464"/>
+          </a:xfrm>
+          <a:prstGeom prst="roundRect">
+            <a:avLst/>
+          </a:prstGeom>
+          <a:solidFill>
+            <a:srgbClr val="D9D9D9"/>
+          </a:solidFill>
+          <a:ln>
+            <a:noFill/>
+          </a:ln>
+        </p:spPr>
+        <p:style>
+          <a:lnRef idx="1">
+            <a:schemeClr val="accent1"/>
+          </a:lnRef>
+          <a:fillRef idx="3">
+            <a:schemeClr val="accent1"/>
+          </a:fillRef>
+          <a:effectRef idx="2">
+            <a:schemeClr val="accent1"/>
+          </a:effectRef>
+          <a:fontRef idx="minor">
+            <a:schemeClr val="lt1"/>
+          </a:fontRef>
+        </p:style>
+        <p:txBody>
+          <a:bodyPr rtlCol="0" anchor="ctr"/>
+          <a:lstStyle/>
+          <a:p>
+            <a:pPr algn="ctr"/>
+          </a:p>
+        </p:txBody>
+      </p:sp>
+      <p:sp>
+        <p:nvSpPr>
+          <p:cNvPr id="30" name="TextBox 29"/>
+          <p:cNvSpPr txBox="1"/>
+          <p:nvPr/>
+        </p:nvSpPr>
+        <p:spPr>
+          <a:xfrm>
+            <a:off x="731520" y="3273551"/>
+            <a:ext cx="2176272" cy="228600"/>
+          </a:xfrm>
+          <a:prstGeom prst="rect">
+            <a:avLst/>
+          </a:prstGeom>
+          <a:noFill/>
+        </p:spPr>
+        <p:txBody>
+          <a:bodyPr wrap="square" lIns="45720" rIns="45720" anchor="ctr">
+            <a:spAutoFit/>
+          </a:bodyPr>
+          <a:lstStyle/>
+          <a:p>
+            <a:pPr algn="l">
+              <a:lnSpc>
+                <a:spcPct val="100000"/>
+              </a:lnSpc>
+              <a:spcBef>
+                <a:spcPts val="0"/>
+              </a:spcBef>
+              <a:spcAft>
+                <a:spcPts val="0"/>
+              </a:spcAft>
+            </a:pPr>
+            <a:r>
+              <a:rPr sz="940" b="0" i="0">
+                <a:solidFill>
+                  <a:srgbClr val="18212B"/>
+                </a:solidFill>
+                <a:latin typeface="Arial"/>
+              </a:rPr>
+              <a:t>Learned model training + tuning</a:t>
+            </a:r>
+          </a:p>
+        </p:txBody>
+      </p:sp>
+      <p:cxnSp>
+        <p:nvCxnSpPr>
+          <p:cNvPr id="31" name="Connector 30"/>
+          <p:cNvCxnSpPr/>
+          <p:nvPr/>
+        </p:nvCxnSpPr>
+        <p:spPr>
+          <a:xfrm>
+            <a:off x="713232" y="3602736"/>
+            <a:ext cx="10442448" cy="0"/>
+          </a:xfrm>
+          <a:prstGeom prst="line">
+            <a:avLst/>
+          </a:prstGeom>
+          <a:ln w="4445">
+            <a:solidFill>
+              <a:srgbClr val="D7D2C8"/>
+            </a:solidFill>
+          </a:ln>
+        </p:spPr>
+        <p:style>
+          <a:lnRef idx="2">
+            <a:schemeClr val="accent1"/>
+          </a:lnRef>
+          <a:fillRef idx="0">
+            <a:schemeClr val="accent1"/>
+          </a:fillRef>
+          <a:effectRef idx="1">
+            <a:schemeClr val="accent1"/>
+          </a:effectRef>
+          <a:fontRef idx="minor">
+            <a:schemeClr val="tx1"/>
+          </a:fontRef>
+        </p:style>
+      </p:cxnSp>
+      <p:sp>
+        <p:nvSpPr>
+          <p:cNvPr id="32" name="Rounded Rectangle 31"/>
+          <p:cNvSpPr/>
+          <p:nvPr/>
+        </p:nvSpPr>
+        <p:spPr>
+          <a:xfrm>
+            <a:off x="4274166" y="3282696"/>
+            <a:ext cx="2140915" cy="283464"/>
+          </a:xfrm>
+          <a:prstGeom prst="roundRect">
+            <a:avLst/>
+          </a:prstGeom>
+          <a:solidFill>
+            <a:srgbClr val="496B5A"/>
+          </a:solidFill>
+          <a:ln>
+            <a:noFill/>
+          </a:ln>
+        </p:spPr>
+        <p:style>
+          <a:lnRef idx="1">
+            <a:schemeClr val="accent1"/>
+          </a:lnRef>
+          <a:fillRef idx="3">
+            <a:schemeClr val="accent1"/>
+          </a:fillRef>
+          <a:effectRef idx="2">
+            <a:schemeClr val="accent1"/>
+          </a:effectRef>
+          <a:fontRef idx="minor">
+            <a:schemeClr val="lt1"/>
+          </a:fontRef>
+        </p:style>
+        <p:txBody>
+          <a:bodyPr rtlCol="0" anchor="ctr"/>
+          <a:lstStyle/>
+          <a:p>
+            <a:pPr algn="ctr"/>
+          </a:p>
+        </p:txBody>
+      </p:sp>
+      <p:sp>
+        <p:nvSpPr>
+          <p:cNvPr id="33" name="TextBox 32"/>
+          <p:cNvSpPr txBox="1"/>
+          <p:nvPr/>
+        </p:nvSpPr>
+        <p:spPr>
+          <a:xfrm>
+            <a:off x="4319886" y="3355848"/>
+            <a:ext cx="2049475" cy="109728"/>
+          </a:xfrm>
+          <a:prstGeom prst="rect">
+            <a:avLst/>
+          </a:prstGeom>
+          <a:noFill/>
+        </p:spPr>
+        <p:txBody>
+          <a:bodyPr wrap="square" lIns="45720" rIns="45720" anchor="ctr">
+            <a:spAutoFit/>
+          </a:bodyPr>
+          <a:lstStyle/>
+          <a:p>
+            <a:pPr algn="ctr">
+              <a:lnSpc>
+                <a:spcPct val="100000"/>
+              </a:lnSpc>
+              <a:spcBef>
+                <a:spcPts val="0"/>
+              </a:spcBef>
+              <a:spcAft>
+                <a:spcPts val="0"/>
+              </a:spcAft>
+            </a:pPr>
+            <a:r>
+              <a:rPr sz="620" b="1" i="0">
+                <a:solidFill>
+                  <a:srgbClr val="FFFFFF"/>
+                </a:solidFill>
+                <a:latin typeface="Cascadia Mono"/>
+              </a:rPr>
+              <a:t>PLANNED</a:t>
+            </a:r>
+          </a:p>
+        </p:txBody>
+      </p:sp>
+      <p:sp>
+        <p:nvSpPr>
+          <p:cNvPr id="34" name="TextBox 33"/>
+          <p:cNvSpPr txBox="1"/>
+          <p:nvPr/>
+        </p:nvSpPr>
+        <p:spPr>
+          <a:xfrm>
+            <a:off x="731520" y="3694176"/>
+            <a:ext cx="2176272" cy="228600"/>
+          </a:xfrm>
+          <a:prstGeom prst="rect">
+            <a:avLst/>
+          </a:prstGeom>
+          <a:noFill/>
+        </p:spPr>
+        <p:txBody>
+          <a:bodyPr wrap="square" lIns="45720" rIns="45720" anchor="ctr">
+            <a:spAutoFit/>
+          </a:bodyPr>
+          <a:lstStyle/>
+          <a:p>
+            <a:pPr algn="l">
+              <a:lnSpc>
+                <a:spcPct val="100000"/>
+              </a:lnSpc>
+              <a:spcBef>
+                <a:spcPts val="0"/>
+              </a:spcBef>
+              <a:spcAft>
+                <a:spcPts val="0"/>
+              </a:spcAft>
+            </a:pPr>
+            <a:r>
+              <a:rPr sz="940" b="0" i="0">
+                <a:solidFill>
+                  <a:srgbClr val="18212B"/>
+                </a:solidFill>
+                <a:latin typeface="Arial"/>
+              </a:rPr>
+              <a:t>Digital feature system + validation</a:t>
+            </a:r>
+          </a:p>
+        </p:txBody>
+      </p:sp>
+      <p:cxnSp>
+        <p:nvCxnSpPr>
+          <p:cNvPr id="35" name="Connector 34"/>
+          <p:cNvCxnSpPr/>
+          <p:nvPr/>
+        </p:nvCxnSpPr>
+        <p:spPr>
+          <a:xfrm>
+            <a:off x="713232" y="4023359"/>
+            <a:ext cx="10442448" cy="0"/>
+          </a:xfrm>
+          <a:prstGeom prst="line">
+            <a:avLst/>
+          </a:prstGeom>
+          <a:ln w="4445">
+            <a:solidFill>
+              <a:srgbClr val="D7D2C8"/>
+            </a:solidFill>
+          </a:ln>
+        </p:spPr>
+        <p:style>
+          <a:lnRef idx="2">
+            <a:schemeClr val="accent1"/>
+          </a:lnRef>
+          <a:fillRef idx="0">
+            <a:schemeClr val="accent1"/>
+          </a:fillRef>
+          <a:effectRef idx="1">
+            <a:schemeClr val="accent1"/>
+          </a:effectRef>
+          <a:fontRef idx="minor">
+            <a:schemeClr val="tx1"/>
+          </a:fontRef>
+        </p:style>
+      </p:cxnSp>
+      <p:sp>
+        <p:nvSpPr>
+          <p:cNvPr id="36" name="Rounded Rectangle 35"/>
+          <p:cNvSpPr/>
+          <p:nvPr/>
+        </p:nvSpPr>
+        <p:spPr>
+          <a:xfrm>
+            <a:off x="6415082" y="3703320"/>
             <a:ext cx="1070457" cy="283464"/>
+          </a:xfrm>
+          <a:prstGeom prst="roundRect">
+            <a:avLst/>
+          </a:prstGeom>
+          <a:solidFill>
+            <a:srgbClr val="8A3346"/>
+          </a:solidFill>
+          <a:ln>
+            <a:noFill/>
+          </a:ln>
+        </p:spPr>
+        <p:style>
+          <a:lnRef idx="1">
+            <a:schemeClr val="accent1"/>
+          </a:lnRef>
+          <a:fillRef idx="3">
+            <a:schemeClr val="accent1"/>
+          </a:fillRef>
+          <a:effectRef idx="2">
+            <a:schemeClr val="accent1"/>
+          </a:effectRef>
+          <a:fontRef idx="minor">
+            <a:schemeClr val="lt1"/>
+          </a:fontRef>
+        </p:style>
+        <p:txBody>
+          <a:bodyPr rtlCol="0" anchor="ctr"/>
+          <a:lstStyle/>
+          <a:p>
+            <a:pPr algn="ctr"/>
+          </a:p>
+        </p:txBody>
+      </p:sp>
+      <p:sp>
+        <p:nvSpPr>
+          <p:cNvPr id="37" name="TextBox 36"/>
+          <p:cNvSpPr txBox="1"/>
+          <p:nvPr/>
+        </p:nvSpPr>
+        <p:spPr>
+          <a:xfrm>
+            <a:off x="6460802" y="3776472"/>
+            <a:ext cx="979017" cy="109728"/>
+          </a:xfrm>
+          <a:prstGeom prst="rect">
+            <a:avLst/>
+          </a:prstGeom>
+          <a:noFill/>
+        </p:spPr>
+        <p:txBody>
+          <a:bodyPr wrap="square" lIns="45720" rIns="45720" anchor="ctr">
+            <a:spAutoFit/>
+          </a:bodyPr>
+          <a:lstStyle/>
+          <a:p>
+            <a:pPr algn="ctr">
+              <a:lnSpc>
+                <a:spcPct val="100000"/>
+              </a:lnSpc>
+              <a:spcBef>
+                <a:spcPts val="0"/>
+              </a:spcBef>
+              <a:spcAft>
+                <a:spcPts val="0"/>
+              </a:spcAft>
+            </a:pPr>
+            <a:r>
+              <a:rPr sz="620" b="1" i="0">
+                <a:solidFill>
+                  <a:srgbClr val="FFFFFF"/>
+                </a:solidFill>
+                <a:latin typeface="Cascadia Mono"/>
+              </a:rPr>
+              <a:t>PLANNED</a:t>
+            </a:r>
+          </a:p>
+        </p:txBody>
+      </p:sp>
+      <p:sp>
+        <p:nvSpPr>
+          <p:cNvPr id="38" name="TextBox 37"/>
+          <p:cNvSpPr txBox="1"/>
+          <p:nvPr/>
+        </p:nvSpPr>
+        <p:spPr>
+          <a:xfrm>
+            <a:off x="731520" y="4114800"/>
+            <a:ext cx="2176272" cy="228600"/>
+          </a:xfrm>
+          <a:prstGeom prst="rect">
+            <a:avLst/>
+          </a:prstGeom>
+          <a:noFill/>
+        </p:spPr>
+        <p:txBody>
+          <a:bodyPr wrap="square" lIns="45720" rIns="45720" anchor="ctr">
+            <a:spAutoFit/>
+          </a:bodyPr>
+          <a:lstStyle/>
+          <a:p>
+            <a:pPr algn="l">
+              <a:lnSpc>
+                <a:spcPct val="100000"/>
+              </a:lnSpc>
+              <a:spcBef>
+                <a:spcPts val="0"/>
+              </a:spcBef>
+              <a:spcAft>
+                <a:spcPts val="0"/>
+              </a:spcAft>
+            </a:pPr>
+            <a:r>
+              <a:rPr sz="940" b="0" i="0">
+                <a:solidFill>
+                  <a:srgbClr val="18212B"/>
+                </a:solidFill>
+                <a:latin typeface="Arial"/>
+              </a:rPr>
+              <a:t>Freeze + single test campaign</a:t>
+            </a:r>
+          </a:p>
+        </p:txBody>
+      </p:sp>
+      <p:cxnSp>
+        <p:nvCxnSpPr>
+          <p:cNvPr id="39" name="Connector 38"/>
+          <p:cNvCxnSpPr/>
+          <p:nvPr/>
+        </p:nvCxnSpPr>
+        <p:spPr>
+          <a:xfrm>
+            <a:off x="713232" y="4443983"/>
+            <a:ext cx="10442448" cy="0"/>
+          </a:xfrm>
+          <a:prstGeom prst="line">
+            <a:avLst/>
+          </a:prstGeom>
+          <a:ln w="4445">
+            <a:solidFill>
+              <a:srgbClr val="D7D2C8"/>
+            </a:solidFill>
+          </a:ln>
+        </p:spPr>
+        <p:style>
+          <a:lnRef idx="2">
+            <a:schemeClr val="accent1"/>
+          </a:lnRef>
+          <a:fillRef idx="0">
+            <a:schemeClr val="accent1"/>
+          </a:fillRef>
+          <a:effectRef idx="1">
+            <a:schemeClr val="accent1"/>
+          </a:effectRef>
+          <a:fontRef idx="minor">
+            <a:schemeClr val="tx1"/>
+          </a:fontRef>
+        </p:style>
+      </p:cxnSp>
+      <p:sp>
+        <p:nvSpPr>
+          <p:cNvPr id="40" name="Rounded Rectangle 39"/>
+          <p:cNvSpPr/>
+          <p:nvPr/>
+        </p:nvSpPr>
+        <p:spPr>
+          <a:xfrm>
+            <a:off x="7485539" y="4123944"/>
+            <a:ext cx="1070457" cy="283464"/>
+          </a:xfrm>
+          <a:prstGeom prst="roundRect">
+            <a:avLst/>
+          </a:prstGeom>
+          <a:solidFill>
+            <a:srgbClr val="A46A28"/>
+          </a:solidFill>
+          <a:ln>
+            <a:noFill/>
+          </a:ln>
+        </p:spPr>
+        <p:style>
+          <a:lnRef idx="1">
+            <a:schemeClr val="accent1"/>
+          </a:lnRef>
+          <a:fillRef idx="3">
+            <a:schemeClr val="accent1"/>
+          </a:fillRef>
+          <a:effectRef idx="2">
+            <a:schemeClr val="accent1"/>
+          </a:effectRef>
+          <a:fontRef idx="minor">
+            <a:schemeClr val="lt1"/>
+          </a:fontRef>
+        </p:style>
+        <p:txBody>
+          <a:bodyPr rtlCol="0" anchor="ctr"/>
+          <a:lstStyle/>
+          <a:p>
+            <a:pPr algn="ctr"/>
+          </a:p>
+        </p:txBody>
+      </p:sp>
+      <p:sp>
+        <p:nvSpPr>
+          <p:cNvPr id="41" name="TextBox 40"/>
+          <p:cNvSpPr txBox="1"/>
+          <p:nvPr/>
+        </p:nvSpPr>
+        <p:spPr>
+          <a:xfrm>
+            <a:off x="7531259" y="4197096"/>
+            <a:ext cx="979017" cy="109728"/>
+          </a:xfrm>
+          <a:prstGeom prst="rect">
+            <a:avLst/>
+          </a:prstGeom>
+          <a:noFill/>
+        </p:spPr>
+        <p:txBody>
+          <a:bodyPr wrap="square" lIns="45720" rIns="45720" anchor="ctr">
+            <a:spAutoFit/>
+          </a:bodyPr>
+          <a:lstStyle/>
+          <a:p>
+            <a:pPr algn="ctr">
+              <a:lnSpc>
+                <a:spcPct val="100000"/>
+              </a:lnSpc>
+              <a:spcBef>
+                <a:spcPts val="0"/>
+              </a:spcBef>
+              <a:spcAft>
+                <a:spcPts val="0"/>
+              </a:spcAft>
+            </a:pPr>
+            <a:r>
+              <a:rPr sz="620" b="1" i="0">
+                <a:solidFill>
+                  <a:srgbClr val="FFFFFF"/>
+                </a:solidFill>
+                <a:latin typeface="Cascadia Mono"/>
+              </a:rPr>
+              <a:t>PLANNED</a:t>
+            </a:r>
+          </a:p>
+        </p:txBody>
+      </p:sp>
+      <p:sp>
+        <p:nvSpPr>
+          <p:cNvPr id="42" name="TextBox 41"/>
+          <p:cNvSpPr txBox="1"/>
+          <p:nvPr/>
+        </p:nvSpPr>
+        <p:spPr>
+          <a:xfrm>
+            <a:off x="731520" y="4535424"/>
+            <a:ext cx="2176272" cy="228600"/>
+          </a:xfrm>
+          <a:prstGeom prst="rect">
+            <a:avLst/>
+          </a:prstGeom>
+          <a:noFill/>
+        </p:spPr>
+        <p:txBody>
+          <a:bodyPr wrap="square" lIns="45720" rIns="45720" anchor="ctr">
+            <a:spAutoFit/>
+          </a:bodyPr>
+          <a:lstStyle/>
+          <a:p>
+            <a:pPr algn="l">
+              <a:lnSpc>
+                <a:spcPct val="100000"/>
+              </a:lnSpc>
+              <a:spcBef>
+                <a:spcPts val="0"/>
+              </a:spcBef>
+              <a:spcAft>
+                <a:spcPts val="0"/>
+              </a:spcAft>
+            </a:pPr>
+            <a:r>
+              <a:rPr sz="940" b="0" i="0">
+                <a:solidFill>
+                  <a:srgbClr val="18212B"/>
+                </a:solidFill>
+                <a:latin typeface="Arial"/>
+              </a:rPr>
+              <a:t>Demo + optional replay</a:t>
+            </a:r>
+          </a:p>
+        </p:txBody>
+      </p:sp>
+      <p:cxnSp>
+        <p:nvCxnSpPr>
+          <p:cNvPr id="43" name="Connector 42"/>
+          <p:cNvCxnSpPr/>
+          <p:nvPr/>
+        </p:nvCxnSpPr>
+        <p:spPr>
+          <a:xfrm>
+            <a:off x="713232" y="4864608"/>
+            <a:ext cx="10442448" cy="0"/>
+          </a:xfrm>
+          <a:prstGeom prst="line">
+            <a:avLst/>
+          </a:prstGeom>
+          <a:ln w="4445">
+            <a:solidFill>
+              <a:srgbClr val="D7D2C8"/>
+            </a:solidFill>
+          </a:ln>
+        </p:spPr>
+        <p:style>
+          <a:lnRef idx="2">
+            <a:schemeClr val="accent1"/>
+          </a:lnRef>
+          <a:fillRef idx="0">
+            <a:schemeClr val="accent1"/>
+          </a:fillRef>
+          <a:effectRef idx="1">
+            <a:schemeClr val="accent1"/>
+          </a:effectRef>
+          <a:fontRef idx="minor">
+            <a:schemeClr val="tx1"/>
+          </a:fontRef>
+        </p:style>
+      </p:cxnSp>
+      <p:sp>
+        <p:nvSpPr>
+          <p:cNvPr id="44" name="Rounded Rectangle 43"/>
+          <p:cNvSpPr/>
+          <p:nvPr/>
+        </p:nvSpPr>
+        <p:spPr>
+          <a:xfrm>
+            <a:off x="8555997" y="4544568"/>
+            <a:ext cx="1070457" cy="283464"/>
+          </a:xfrm>
+          <a:prstGeom prst="roundRect">
+            <a:avLst/>
+          </a:prstGeom>
+          <a:solidFill>
+            <a:srgbClr val="A46A28"/>
+          </a:solidFill>
+          <a:ln>
+            <a:noFill/>
+          </a:ln>
+        </p:spPr>
+        <p:style>
+          <a:lnRef idx="1">
+            <a:schemeClr val="accent1"/>
+          </a:lnRef>
+          <a:fillRef idx="3">
+            <a:schemeClr val="accent1"/>
+          </a:fillRef>
+          <a:effectRef idx="2">
+            <a:schemeClr val="accent1"/>
+          </a:effectRef>
+          <a:fontRef idx="minor">
+            <a:schemeClr val="lt1"/>
+          </a:fontRef>
+        </p:style>
+        <p:txBody>
+          <a:bodyPr rtlCol="0" anchor="ctr"/>
+          <a:lstStyle/>
+          <a:p>
+            <a:pPr algn="ctr"/>
+          </a:p>
+        </p:txBody>
+      </p:sp>
+      <p:sp>
+        <p:nvSpPr>
+          <p:cNvPr id="45" name="TextBox 44"/>
+          <p:cNvSpPr txBox="1"/>
+          <p:nvPr/>
+        </p:nvSpPr>
+        <p:spPr>
+          <a:xfrm>
+            <a:off x="8601717" y="4617720"/>
+            <a:ext cx="979017" cy="109728"/>
+          </a:xfrm>
+          <a:prstGeom prst="rect">
+            <a:avLst/>
+          </a:prstGeom>
+          <a:noFill/>
+        </p:spPr>
+        <p:txBody>
+          <a:bodyPr wrap="square" lIns="45720" rIns="45720" anchor="ctr">
+            <a:spAutoFit/>
+          </a:bodyPr>
+          <a:lstStyle/>
+          <a:p>
+            <a:pPr algn="ctr">
+              <a:lnSpc>
+                <a:spcPct val="100000"/>
+              </a:lnSpc>
+              <a:spcBef>
+                <a:spcPts val="0"/>
+              </a:spcBef>
+              <a:spcAft>
+                <a:spcPts val="0"/>
+              </a:spcAft>
+            </a:pPr>
+            <a:r>
+              <a:rPr sz="620" b="1" i="0">
+                <a:solidFill>
+                  <a:srgbClr val="FFFFFF"/>
+                </a:solidFill>
+                <a:latin typeface="Cascadia Mono"/>
+              </a:rPr>
+              <a:t>PLANNED</a:t>
+            </a:r>
+          </a:p>
+        </p:txBody>
+      </p:sp>
+      <p:sp>
+        <p:nvSpPr>
+          <p:cNvPr id="46" name="TextBox 45"/>
+          <p:cNvSpPr txBox="1"/>
+          <p:nvPr/>
+        </p:nvSpPr>
+        <p:spPr>
+          <a:xfrm>
+            <a:off x="731520" y="4956048"/>
+            <a:ext cx="2176272" cy="228600"/>
+          </a:xfrm>
+          <a:prstGeom prst="rect">
+            <a:avLst/>
+          </a:prstGeom>
+          <a:noFill/>
+        </p:spPr>
+        <p:txBody>
+          <a:bodyPr wrap="square" lIns="45720" rIns="45720" anchor="ctr">
+            <a:spAutoFit/>
+          </a:bodyPr>
+          <a:lstStyle/>
+          <a:p>
+            <a:pPr algn="l">
+              <a:lnSpc>
+                <a:spcPct val="100000"/>
+              </a:lnSpc>
+              <a:spcBef>
+                <a:spcPts val="0"/>
+              </a:spcBef>
+              <a:spcAft>
+                <a:spcPts val="0"/>
+              </a:spcAft>
+            </a:pPr>
+            <a:r>
+              <a:rPr sz="940" b="0" i="0">
+                <a:solidFill>
+                  <a:srgbClr val="18212B"/>
+                </a:solidFill>
+                <a:latin typeface="Arial"/>
+              </a:rPr>
+              <a:t>Report, audit + final review</a:t>
+            </a:r>
+          </a:p>
+        </p:txBody>
+      </p:sp>
+      <p:cxnSp>
+        <p:nvCxnSpPr>
+          <p:cNvPr id="47" name="Connector 46"/>
+          <p:cNvCxnSpPr/>
+          <p:nvPr/>
+        </p:nvCxnSpPr>
+        <p:spPr>
+          <a:xfrm>
+            <a:off x="713232" y="5285231"/>
+            <a:ext cx="10442448" cy="0"/>
+          </a:xfrm>
+          <a:prstGeom prst="line">
+            <a:avLst/>
+          </a:prstGeom>
+          <a:ln w="4445">
+            <a:solidFill>
+              <a:srgbClr val="D7D2C8"/>
+            </a:solidFill>
+          </a:ln>
+        </p:spPr>
+        <p:style>
+          <a:lnRef idx="2">
+            <a:schemeClr val="accent1"/>
+          </a:lnRef>
+          <a:fillRef idx="0">
+            <a:schemeClr val="accent1"/>
+          </a:fillRef>
+          <a:effectRef idx="1">
+            <a:schemeClr val="accent1"/>
+          </a:effectRef>
+          <a:fontRef idx="minor">
+            <a:schemeClr val="tx1"/>
+          </a:fontRef>
+        </p:style>
+      </p:cxnSp>
+      <p:sp>
+        <p:nvSpPr>
+          <p:cNvPr id="48" name="Rounded Rectangle 47"/>
+          <p:cNvSpPr/>
+          <p:nvPr/>
+        </p:nvSpPr>
+        <p:spPr>
+          <a:xfrm>
+            <a:off x="9626454" y="4965192"/>
+            <a:ext cx="1529225" cy="283464"/>
           </a:xfrm>
           <a:prstGeom prst="roundRect">
             <a:avLst/>
@@ -23864,14 +25040,14 @@
       </p:sp>
       <p:sp>
         <p:nvSpPr>
-          <p:cNvPr id="24" name="TextBox 23"/>
-          <p:cNvSpPr txBox="1"/>
-          <p:nvPr/>
-        </p:nvSpPr>
-        <p:spPr>
-          <a:xfrm>
-            <a:off x="3172968" y="2093976"/>
-            <a:ext cx="979017" cy="109728"/>
+          <p:cNvPr id="49" name="TextBox 48"/>
+          <p:cNvSpPr txBox="1"/>
+          <p:nvPr/>
+        </p:nvSpPr>
+        <p:spPr>
+          <a:xfrm>
+            <a:off x="9672174" y="5038344"/>
+            <a:ext cx="1437785" cy="109728"/>
           </a:xfrm>
           <a:prstGeom prst="rect">
             <a:avLst/>
@@ -23902,73 +25078,28 @@
                 </a:solidFill>
                 <a:latin typeface="Cascadia Mono"/>
               </a:rPr>
-              <a:t>IN PROGRESS</a:t>
-            </a:r>
-          </a:p>
-        </p:txBody>
-      </p:sp>
-      <p:sp>
-        <p:nvSpPr>
-          <p:cNvPr id="25" name="TextBox 24"/>
-          <p:cNvSpPr txBox="1"/>
-          <p:nvPr/>
-        </p:nvSpPr>
-        <p:spPr>
-          <a:xfrm>
-            <a:off x="731520" y="2496312"/>
-            <a:ext cx="2176272" cy="228600"/>
-          </a:xfrm>
-          <a:prstGeom prst="rect">
-            <a:avLst/>
-          </a:prstGeom>
-          <a:noFill/>
-        </p:spPr>
-        <p:txBody>
-          <a:bodyPr wrap="square" lIns="45720" rIns="45720" anchor="ctr">
-            <a:spAutoFit/>
-          </a:bodyPr>
-          <a:lstStyle/>
-          <a:p>
-            <a:pPr algn="l">
-              <a:lnSpc>
-                <a:spcPct val="100000"/>
-              </a:lnSpc>
-              <a:spcBef>
-                <a:spcPts val="0"/>
-              </a:spcBef>
-              <a:spcAft>
-                <a:spcPts val="0"/>
-              </a:spcAft>
-            </a:pPr>
-            <a:r>
-              <a:rPr sz="940" b="0" i="0">
-                <a:solidFill>
-                  <a:srgbClr val="18212B"/>
-                </a:solidFill>
-                <a:latin typeface="Arial"/>
-              </a:rPr>
-              <a:t>Learned model training + tuning</a:t>
+              <a:t>PLANNED</a:t>
             </a:r>
           </a:p>
         </p:txBody>
       </p:sp>
       <p:cxnSp>
         <p:nvCxnSpPr>
-          <p:cNvPr id="26" name="Connector 25"/>
+          <p:cNvPr id="50" name="Connector 49"/>
           <p:cNvCxnSpPr/>
           <p:nvPr/>
         </p:nvCxnSpPr>
         <p:spPr>
           <a:xfrm>
-            <a:off x="713232" y="2889504"/>
-            <a:ext cx="10442448" cy="0"/>
+            <a:off x="3815399" y="1719072"/>
+            <a:ext cx="0" cy="3685032"/>
           </a:xfrm>
           <a:prstGeom prst="line">
             <a:avLst/>
           </a:prstGeom>
-          <a:ln w="4445">
+          <a:ln w="10160">
             <a:solidFill>
-              <a:srgbClr val="D7D2C8"/>
+              <a:srgbClr val="8A3346"/>
             </a:solidFill>
           </a:ln>
         </p:spPr>
@@ -23989,20 +25120,20 @@
       </p:cxnSp>
       <p:sp>
         <p:nvSpPr>
-          <p:cNvPr id="27" name="Rounded Rectangle 26"/>
+          <p:cNvPr id="51" name="Oval 50"/>
           <p:cNvSpPr/>
           <p:nvPr/>
         </p:nvSpPr>
         <p:spPr>
           <a:xfrm>
-            <a:off x="4274166" y="2505456"/>
-            <a:ext cx="2140915" cy="283464"/>
-          </a:xfrm>
-          <a:prstGeom prst="roundRect">
+            <a:off x="3765107" y="1755648"/>
+            <a:ext cx="100584" cy="100584"/>
+          </a:xfrm>
+          <a:prstGeom prst="ellipse">
             <a:avLst/>
           </a:prstGeom>
           <a:solidFill>
-            <a:srgbClr val="496B5A"/>
+            <a:srgbClr val="8A3346"/>
           </a:solidFill>
           <a:ln>
             <a:noFill/>
@@ -24030,113 +25161,23 @@
           </a:p>
         </p:txBody>
       </p:sp>
-      <p:sp>
-        <p:nvSpPr>
-          <p:cNvPr id="28" name="TextBox 27"/>
-          <p:cNvSpPr txBox="1"/>
-          <p:nvPr/>
-        </p:nvSpPr>
-        <p:spPr>
-          <a:xfrm>
-            <a:off x="4319886" y="2578608"/>
-            <a:ext cx="2049475" cy="109728"/>
-          </a:xfrm>
-          <a:prstGeom prst="rect">
-            <a:avLst/>
-          </a:prstGeom>
-          <a:noFill/>
-        </p:spPr>
-        <p:txBody>
-          <a:bodyPr wrap="square" lIns="45720" rIns="45720" anchor="ctr">
-            <a:spAutoFit/>
-          </a:bodyPr>
-          <a:lstStyle/>
-          <a:p>
-            <a:pPr algn="ctr">
-              <a:lnSpc>
-                <a:spcPct val="100000"/>
-              </a:lnSpc>
-              <a:spcBef>
-                <a:spcPts val="0"/>
-              </a:spcBef>
-              <a:spcAft>
-                <a:spcPts val="0"/>
-              </a:spcAft>
-            </a:pPr>
-            <a:r>
-              <a:rPr sz="620" b="1" i="0">
-                <a:solidFill>
-                  <a:srgbClr val="FFFFFF"/>
-                </a:solidFill>
-                <a:latin typeface="Cascadia Mono"/>
-              </a:rPr>
-              <a:t>PLANNED</a:t>
-            </a:r>
-          </a:p>
-        </p:txBody>
-      </p:sp>
-      <p:sp>
-        <p:nvSpPr>
-          <p:cNvPr id="29" name="TextBox 28"/>
-          <p:cNvSpPr txBox="1"/>
-          <p:nvPr/>
-        </p:nvSpPr>
-        <p:spPr>
-          <a:xfrm>
-            <a:off x="731520" y="2980944"/>
-            <a:ext cx="2176272" cy="228600"/>
-          </a:xfrm>
-          <a:prstGeom prst="rect">
-            <a:avLst/>
-          </a:prstGeom>
-          <a:noFill/>
-        </p:spPr>
-        <p:txBody>
-          <a:bodyPr wrap="square" lIns="45720" rIns="45720" anchor="ctr">
-            <a:spAutoFit/>
-          </a:bodyPr>
-          <a:lstStyle/>
-          <a:p>
-            <a:pPr algn="l">
-              <a:lnSpc>
-                <a:spcPct val="100000"/>
-              </a:lnSpc>
-              <a:spcBef>
-                <a:spcPts val="0"/>
-              </a:spcBef>
-              <a:spcAft>
-                <a:spcPts val="0"/>
-              </a:spcAft>
-            </a:pPr>
-            <a:r>
-              <a:rPr sz="940" b="0" i="0">
-                <a:solidFill>
-                  <a:srgbClr val="18212B"/>
-                </a:solidFill>
-                <a:latin typeface="Arial"/>
-              </a:rPr>
-              <a:t>Digital feature system + validation</a:t>
-            </a:r>
-          </a:p>
-        </p:txBody>
-      </p:sp>
       <p:cxnSp>
         <p:nvCxnSpPr>
-          <p:cNvPr id="30" name="Connector 29"/>
+          <p:cNvPr id="52" name="Connector 51"/>
           <p:cNvCxnSpPr/>
           <p:nvPr/>
         </p:nvCxnSpPr>
         <p:spPr>
           <a:xfrm>
-            <a:off x="713232" y="3374136"/>
-            <a:ext cx="10442448" cy="0"/>
+            <a:off x="7026772" y="1719072"/>
+            <a:ext cx="0" cy="3685032"/>
           </a:xfrm>
           <a:prstGeom prst="line">
             <a:avLst/>
           </a:prstGeom>
-          <a:ln w="4445">
+          <a:ln w="10160">
             <a:solidFill>
-              <a:srgbClr val="D7D2C8"/>
+              <a:srgbClr val="203A57"/>
             </a:solidFill>
           </a:ln>
         </p:spPr>
@@ -24157,16 +25198,172 @@
       </p:cxnSp>
       <p:sp>
         <p:nvSpPr>
-          <p:cNvPr id="31" name="Rounded Rectangle 30"/>
+          <p:cNvPr id="53" name="Oval 52"/>
           <p:cNvSpPr/>
           <p:nvPr/>
         </p:nvSpPr>
         <p:spPr>
           <a:xfrm>
-            <a:off x="6415082" y="2990088"/>
-            <a:ext cx="1070457" cy="283464"/>
-          </a:xfrm>
-          <a:prstGeom prst="roundRect">
+            <a:off x="6976480" y="1755648"/>
+            <a:ext cx="100584" cy="100584"/>
+          </a:xfrm>
+          <a:prstGeom prst="ellipse">
+            <a:avLst/>
+          </a:prstGeom>
+          <a:solidFill>
+            <a:srgbClr val="203A57"/>
+          </a:solidFill>
+          <a:ln>
+            <a:noFill/>
+          </a:ln>
+        </p:spPr>
+        <p:style>
+          <a:lnRef idx="1">
+            <a:schemeClr val="accent1"/>
+          </a:lnRef>
+          <a:fillRef idx="3">
+            <a:schemeClr val="accent1"/>
+          </a:fillRef>
+          <a:effectRef idx="2">
+            <a:schemeClr val="accent1"/>
+          </a:effectRef>
+          <a:fontRef idx="minor">
+            <a:schemeClr val="lt1"/>
+          </a:fontRef>
+        </p:style>
+        <p:txBody>
+          <a:bodyPr rtlCol="0" anchor="ctr"/>
+          <a:lstStyle/>
+          <a:p>
+            <a:pPr algn="ctr"/>
+          </a:p>
+        </p:txBody>
+      </p:sp>
+      <p:cxnSp>
+        <p:nvCxnSpPr>
+          <p:cNvPr id="54" name="Connector 53"/>
+          <p:cNvCxnSpPr/>
+          <p:nvPr/>
+        </p:nvCxnSpPr>
+        <p:spPr>
+          <a:xfrm>
+            <a:off x="10773373" y="1719072"/>
+            <a:ext cx="0" cy="3685032"/>
+          </a:xfrm>
+          <a:prstGeom prst="line">
+            <a:avLst/>
+          </a:prstGeom>
+          <a:ln w="10160">
+            <a:solidFill>
+              <a:srgbClr val="203A57"/>
+            </a:solidFill>
+          </a:ln>
+        </p:spPr>
+        <p:style>
+          <a:lnRef idx="2">
+            <a:schemeClr val="accent1"/>
+          </a:lnRef>
+          <a:fillRef idx="0">
+            <a:schemeClr val="accent1"/>
+          </a:fillRef>
+          <a:effectRef idx="1">
+            <a:schemeClr val="accent1"/>
+          </a:effectRef>
+          <a:fontRef idx="minor">
+            <a:schemeClr val="tx1"/>
+          </a:fontRef>
+        </p:style>
+      </p:cxnSp>
+      <p:sp>
+        <p:nvSpPr>
+          <p:cNvPr id="55" name="Oval 54"/>
+          <p:cNvSpPr/>
+          <p:nvPr/>
+        </p:nvSpPr>
+        <p:spPr>
+          <a:xfrm>
+            <a:off x="10723081" y="1755648"/>
+            <a:ext cx="100584" cy="100584"/>
+          </a:xfrm>
+          <a:prstGeom prst="ellipse">
+            <a:avLst/>
+          </a:prstGeom>
+          <a:solidFill>
+            <a:srgbClr val="203A57"/>
+          </a:solidFill>
+          <a:ln>
+            <a:noFill/>
+          </a:ln>
+        </p:spPr>
+        <p:style>
+          <a:lnRef idx="1">
+            <a:schemeClr val="accent1"/>
+          </a:lnRef>
+          <a:fillRef idx="3">
+            <a:schemeClr val="accent1"/>
+          </a:fillRef>
+          <a:effectRef idx="2">
+            <a:schemeClr val="accent1"/>
+          </a:effectRef>
+          <a:fontRef idx="minor">
+            <a:schemeClr val="lt1"/>
+          </a:fontRef>
+        </p:style>
+        <p:txBody>
+          <a:bodyPr rtlCol="0" anchor="ctr"/>
+          <a:lstStyle/>
+          <a:p>
+            <a:pPr algn="ctr"/>
+          </a:p>
+        </p:txBody>
+      </p:sp>
+      <p:cxnSp>
+        <p:nvCxnSpPr>
+          <p:cNvPr id="56" name="Connector 55"/>
+          <p:cNvCxnSpPr/>
+          <p:nvPr/>
+        </p:nvCxnSpPr>
+        <p:spPr>
+          <a:xfrm>
+            <a:off x="11002757" y="1719072"/>
+            <a:ext cx="0" cy="3685032"/>
+          </a:xfrm>
+          <a:prstGeom prst="line">
+            <a:avLst/>
+          </a:prstGeom>
+          <a:ln w="10160">
+            <a:solidFill>
+              <a:srgbClr val="8A3346"/>
+            </a:solidFill>
+          </a:ln>
+        </p:spPr>
+        <p:style>
+          <a:lnRef idx="2">
+            <a:schemeClr val="accent1"/>
+          </a:lnRef>
+          <a:fillRef idx="0">
+            <a:schemeClr val="accent1"/>
+          </a:fillRef>
+          <a:effectRef idx="1">
+            <a:schemeClr val="accent1"/>
+          </a:effectRef>
+          <a:fontRef idx="minor">
+            <a:schemeClr val="tx1"/>
+          </a:fontRef>
+        </p:style>
+      </p:cxnSp>
+      <p:sp>
+        <p:nvSpPr>
+          <p:cNvPr id="57" name="Oval 56"/>
+          <p:cNvSpPr/>
+          <p:nvPr/>
+        </p:nvSpPr>
+        <p:spPr>
+          <a:xfrm>
+            <a:off x="10952465" y="1755648"/>
+            <a:ext cx="100584" cy="100584"/>
+          </a:xfrm>
+          <a:prstGeom prst="ellipse">
             <a:avLst/>
           </a:prstGeom>
           <a:solidFill>
@@ -24200,148 +25397,23 @@
       </p:sp>
       <p:sp>
         <p:nvSpPr>
-          <p:cNvPr id="32" name="TextBox 31"/>
-          <p:cNvSpPr txBox="1"/>
-          <p:nvPr/>
-        </p:nvSpPr>
-        <p:spPr>
-          <a:xfrm>
-            <a:off x="6460802" y="3063240"/>
-            <a:ext cx="979017" cy="109728"/>
-          </a:xfrm>
-          <a:prstGeom prst="rect">
-            <a:avLst/>
-          </a:prstGeom>
-          <a:noFill/>
-        </p:spPr>
-        <p:txBody>
-          <a:bodyPr wrap="square" lIns="45720" rIns="45720" anchor="ctr">
-            <a:spAutoFit/>
-          </a:bodyPr>
-          <a:lstStyle/>
-          <a:p>
-            <a:pPr algn="ctr">
-              <a:lnSpc>
-                <a:spcPct val="100000"/>
-              </a:lnSpc>
-              <a:spcBef>
-                <a:spcPts val="0"/>
-              </a:spcBef>
-              <a:spcAft>
-                <a:spcPts val="0"/>
-              </a:spcAft>
-            </a:pPr>
-            <a:r>
-              <a:rPr sz="620" b="1" i="0">
-                <a:solidFill>
-                  <a:srgbClr val="FFFFFF"/>
-                </a:solidFill>
-                <a:latin typeface="Cascadia Mono"/>
-              </a:rPr>
-              <a:t>PLANNED</a:t>
-            </a:r>
-          </a:p>
-        </p:txBody>
-      </p:sp>
-      <p:sp>
-        <p:nvSpPr>
-          <p:cNvPr id="33" name="TextBox 32"/>
-          <p:cNvSpPr txBox="1"/>
-          <p:nvPr/>
-        </p:nvSpPr>
-        <p:spPr>
-          <a:xfrm>
-            <a:off x="731520" y="3465575"/>
-            <a:ext cx="2176272" cy="228600"/>
-          </a:xfrm>
-          <a:prstGeom prst="rect">
-            <a:avLst/>
-          </a:prstGeom>
-          <a:noFill/>
-        </p:spPr>
-        <p:txBody>
-          <a:bodyPr wrap="square" lIns="45720" rIns="45720" anchor="ctr">
-            <a:spAutoFit/>
-          </a:bodyPr>
-          <a:lstStyle/>
-          <a:p>
-            <a:pPr algn="l">
-              <a:lnSpc>
-                <a:spcPct val="100000"/>
-              </a:lnSpc>
-              <a:spcBef>
-                <a:spcPts val="0"/>
-              </a:spcBef>
-              <a:spcAft>
-                <a:spcPts val="0"/>
-              </a:spcAft>
-            </a:pPr>
-            <a:r>
-              <a:rPr sz="940" b="0" i="0">
-                <a:solidFill>
-                  <a:srgbClr val="18212B"/>
-                </a:solidFill>
-                <a:latin typeface="Arial"/>
-              </a:rPr>
-              <a:t>Freeze + single test campaign</a:t>
-            </a:r>
-          </a:p>
-        </p:txBody>
-      </p:sp>
-      <p:cxnSp>
-        <p:nvCxnSpPr>
-          <p:cNvPr id="34" name="Connector 33"/>
-          <p:cNvCxnSpPr/>
-          <p:nvPr/>
-        </p:nvCxnSpPr>
-        <p:spPr>
-          <a:xfrm>
-            <a:off x="713232" y="3858768"/>
-            <a:ext cx="10442448" cy="0"/>
-          </a:xfrm>
-          <a:prstGeom prst="line">
-            <a:avLst/>
-          </a:prstGeom>
-          <a:ln w="4445">
+          <p:cNvPr id="58" name="Rectangle 57"/>
+          <p:cNvSpPr/>
+          <p:nvPr/>
+        </p:nvSpPr>
+        <p:spPr>
+          <a:xfrm>
+            <a:off x="10161683" y="4928616"/>
+            <a:ext cx="535228" cy="356616"/>
+          </a:xfrm>
+          <a:prstGeom prst="rect">
+            <a:avLst/>
+          </a:prstGeom>
+          <a:noFill/>
+          <a:ln w="13970">
             <a:solidFill>
-              <a:srgbClr val="D7D2C8"/>
+              <a:srgbClr val="8A3346"/>
             </a:solidFill>
-          </a:ln>
-        </p:spPr>
-        <p:style>
-          <a:lnRef idx="2">
-            <a:schemeClr val="accent1"/>
-          </a:lnRef>
-          <a:fillRef idx="0">
-            <a:schemeClr val="accent1"/>
-          </a:fillRef>
-          <a:effectRef idx="1">
-            <a:schemeClr val="accent1"/>
-          </a:effectRef>
-          <a:fontRef idx="minor">
-            <a:schemeClr val="tx1"/>
-          </a:fontRef>
-        </p:style>
-      </p:cxnSp>
-      <p:sp>
-        <p:nvSpPr>
-          <p:cNvPr id="35" name="Rounded Rectangle 34"/>
-          <p:cNvSpPr/>
-          <p:nvPr/>
-        </p:nvSpPr>
-        <p:spPr>
-          <a:xfrm>
-            <a:off x="7485539" y="3474720"/>
-            <a:ext cx="1070457" cy="283464"/>
-          </a:xfrm>
-          <a:prstGeom prst="roundRect">
-            <a:avLst/>
-          </a:prstGeom>
-          <a:solidFill>
-            <a:srgbClr val="A46A28"/>
-          </a:solidFill>
-          <a:ln>
-            <a:noFill/>
           </a:ln>
         </p:spPr>
         <p:style>
@@ -24368,22 +25440,22 @@
       </p:sp>
       <p:sp>
         <p:nvSpPr>
-          <p:cNvPr id="36" name="TextBox 35"/>
-          <p:cNvSpPr txBox="1"/>
-          <p:nvPr/>
-        </p:nvSpPr>
-        <p:spPr>
-          <a:xfrm>
-            <a:off x="7531259" y="3547872"/>
-            <a:ext cx="979017" cy="109728"/>
-          </a:xfrm>
-          <a:prstGeom prst="rect">
-            <a:avLst/>
-          </a:prstGeom>
-          <a:noFill/>
-        </p:spPr>
-        <p:txBody>
-          <a:bodyPr wrap="square" lIns="45720" rIns="45720" anchor="ctr">
+          <p:cNvPr id="59" name="TextBox 58"/>
+          <p:cNvSpPr txBox="1"/>
+          <p:nvPr/>
+        </p:nvSpPr>
+        <p:spPr>
+          <a:xfrm>
+            <a:off x="10161683" y="5312664"/>
+            <a:ext cx="535228" cy="128016"/>
+          </a:xfrm>
+          <a:prstGeom prst="rect">
+            <a:avLst/>
+          </a:prstGeom>
+          <a:noFill/>
+        </p:spPr>
+        <p:txBody>
+          <a:bodyPr wrap="square" lIns="45720" rIns="45720" anchor="t">
             <a:spAutoFit/>
           </a:bodyPr>
           <a:lstStyle/>
@@ -24400,748 +25472,12 @@
               </a:spcAft>
             </a:pPr>
             <a:r>
-              <a:rPr sz="620" b="1" i="0">
-                <a:solidFill>
-                  <a:srgbClr val="FFFFFF"/>
+              <a:rPr sz="610" b="0" i="0">
+                <a:solidFill>
+                  <a:srgbClr val="8A3346"/>
                 </a:solidFill>
                 <a:latin typeface="Cascadia Mono"/>
               </a:rPr>
-              <a:t>PLANNED</a:t>
-            </a:r>
-          </a:p>
-        </p:txBody>
-      </p:sp>
-      <p:sp>
-        <p:nvSpPr>
-          <p:cNvPr id="37" name="TextBox 36"/>
-          <p:cNvSpPr txBox="1"/>
-          <p:nvPr/>
-        </p:nvSpPr>
-        <p:spPr>
-          <a:xfrm>
-            <a:off x="731520" y="3950208"/>
-            <a:ext cx="2176272" cy="228600"/>
-          </a:xfrm>
-          <a:prstGeom prst="rect">
-            <a:avLst/>
-          </a:prstGeom>
-          <a:noFill/>
-        </p:spPr>
-        <p:txBody>
-          <a:bodyPr wrap="square" lIns="45720" rIns="45720" anchor="ctr">
-            <a:spAutoFit/>
-          </a:bodyPr>
-          <a:lstStyle/>
-          <a:p>
-            <a:pPr algn="l">
-              <a:lnSpc>
-                <a:spcPct val="100000"/>
-              </a:lnSpc>
-              <a:spcBef>
-                <a:spcPts val="0"/>
-              </a:spcBef>
-              <a:spcAft>
-                <a:spcPts val="0"/>
-              </a:spcAft>
-            </a:pPr>
-            <a:r>
-              <a:rPr sz="940" b="0" i="0">
-                <a:solidFill>
-                  <a:srgbClr val="18212B"/>
-                </a:solidFill>
-                <a:latin typeface="Arial"/>
-              </a:rPr>
-              <a:t>Demo + optional replay</a:t>
-            </a:r>
-          </a:p>
-        </p:txBody>
-      </p:sp>
-      <p:cxnSp>
-        <p:nvCxnSpPr>
-          <p:cNvPr id="38" name="Connector 37"/>
-          <p:cNvCxnSpPr/>
-          <p:nvPr/>
-        </p:nvCxnSpPr>
-        <p:spPr>
-          <a:xfrm>
-            <a:off x="713232" y="4343400"/>
-            <a:ext cx="10442448" cy="0"/>
-          </a:xfrm>
-          <a:prstGeom prst="line">
-            <a:avLst/>
-          </a:prstGeom>
-          <a:ln w="4445">
-            <a:solidFill>
-              <a:srgbClr val="D7D2C8"/>
-            </a:solidFill>
-          </a:ln>
-        </p:spPr>
-        <p:style>
-          <a:lnRef idx="2">
-            <a:schemeClr val="accent1"/>
-          </a:lnRef>
-          <a:fillRef idx="0">
-            <a:schemeClr val="accent1"/>
-          </a:fillRef>
-          <a:effectRef idx="1">
-            <a:schemeClr val="accent1"/>
-          </a:effectRef>
-          <a:fontRef idx="minor">
-            <a:schemeClr val="tx1"/>
-          </a:fontRef>
-        </p:style>
-      </p:cxnSp>
-      <p:sp>
-        <p:nvSpPr>
-          <p:cNvPr id="39" name="Rounded Rectangle 38"/>
-          <p:cNvSpPr/>
-          <p:nvPr/>
-        </p:nvSpPr>
-        <p:spPr>
-          <a:xfrm>
-            <a:off x="8555997" y="3959352"/>
-            <a:ext cx="1070457" cy="283464"/>
-          </a:xfrm>
-          <a:prstGeom prst="roundRect">
-            <a:avLst/>
-          </a:prstGeom>
-          <a:solidFill>
-            <a:srgbClr val="A46A28"/>
-          </a:solidFill>
-          <a:ln>
-            <a:noFill/>
-          </a:ln>
-        </p:spPr>
-        <p:style>
-          <a:lnRef idx="1">
-            <a:schemeClr val="accent1"/>
-          </a:lnRef>
-          <a:fillRef idx="3">
-            <a:schemeClr val="accent1"/>
-          </a:fillRef>
-          <a:effectRef idx="2">
-            <a:schemeClr val="accent1"/>
-          </a:effectRef>
-          <a:fontRef idx="minor">
-            <a:schemeClr val="lt1"/>
-          </a:fontRef>
-        </p:style>
-        <p:txBody>
-          <a:bodyPr rtlCol="0" anchor="ctr"/>
-          <a:lstStyle/>
-          <a:p>
-            <a:pPr algn="ctr"/>
-          </a:p>
-        </p:txBody>
-      </p:sp>
-      <p:sp>
-        <p:nvSpPr>
-          <p:cNvPr id="40" name="TextBox 39"/>
-          <p:cNvSpPr txBox="1"/>
-          <p:nvPr/>
-        </p:nvSpPr>
-        <p:spPr>
-          <a:xfrm>
-            <a:off x="8601717" y="4032504"/>
-            <a:ext cx="979017" cy="109728"/>
-          </a:xfrm>
-          <a:prstGeom prst="rect">
-            <a:avLst/>
-          </a:prstGeom>
-          <a:noFill/>
-        </p:spPr>
-        <p:txBody>
-          <a:bodyPr wrap="square" lIns="45720" rIns="45720" anchor="ctr">
-            <a:spAutoFit/>
-          </a:bodyPr>
-          <a:lstStyle/>
-          <a:p>
-            <a:pPr algn="ctr">
-              <a:lnSpc>
-                <a:spcPct val="100000"/>
-              </a:lnSpc>
-              <a:spcBef>
-                <a:spcPts val="0"/>
-              </a:spcBef>
-              <a:spcAft>
-                <a:spcPts val="0"/>
-              </a:spcAft>
-            </a:pPr>
-            <a:r>
-              <a:rPr sz="620" b="1" i="0">
-                <a:solidFill>
-                  <a:srgbClr val="FFFFFF"/>
-                </a:solidFill>
-                <a:latin typeface="Cascadia Mono"/>
-              </a:rPr>
-              <a:t>PLANNED</a:t>
-            </a:r>
-          </a:p>
-        </p:txBody>
-      </p:sp>
-      <p:sp>
-        <p:nvSpPr>
-          <p:cNvPr id="41" name="TextBox 40"/>
-          <p:cNvSpPr txBox="1"/>
-          <p:nvPr/>
-        </p:nvSpPr>
-        <p:spPr>
-          <a:xfrm>
-            <a:off x="731520" y="4434840"/>
-            <a:ext cx="2176272" cy="228600"/>
-          </a:xfrm>
-          <a:prstGeom prst="rect">
-            <a:avLst/>
-          </a:prstGeom>
-          <a:noFill/>
-        </p:spPr>
-        <p:txBody>
-          <a:bodyPr wrap="square" lIns="45720" rIns="45720" anchor="ctr">
-            <a:spAutoFit/>
-          </a:bodyPr>
-          <a:lstStyle/>
-          <a:p>
-            <a:pPr algn="l">
-              <a:lnSpc>
-                <a:spcPct val="100000"/>
-              </a:lnSpc>
-              <a:spcBef>
-                <a:spcPts val="0"/>
-              </a:spcBef>
-              <a:spcAft>
-                <a:spcPts val="0"/>
-              </a:spcAft>
-            </a:pPr>
-            <a:r>
-              <a:rPr sz="940" b="0" i="0">
-                <a:solidFill>
-                  <a:srgbClr val="18212B"/>
-                </a:solidFill>
-                <a:latin typeface="Arial"/>
-              </a:rPr>
-              <a:t>Report, audit + final review</a:t>
-            </a:r>
-          </a:p>
-        </p:txBody>
-      </p:sp>
-      <p:cxnSp>
-        <p:nvCxnSpPr>
-          <p:cNvPr id="42" name="Connector 41"/>
-          <p:cNvCxnSpPr/>
-          <p:nvPr/>
-        </p:nvCxnSpPr>
-        <p:spPr>
-          <a:xfrm>
-            <a:off x="713232" y="4828032"/>
-            <a:ext cx="10442448" cy="0"/>
-          </a:xfrm>
-          <a:prstGeom prst="line">
-            <a:avLst/>
-          </a:prstGeom>
-          <a:ln w="4445">
-            <a:solidFill>
-              <a:srgbClr val="D7D2C8"/>
-            </a:solidFill>
-          </a:ln>
-        </p:spPr>
-        <p:style>
-          <a:lnRef idx="2">
-            <a:schemeClr val="accent1"/>
-          </a:lnRef>
-          <a:fillRef idx="0">
-            <a:schemeClr val="accent1"/>
-          </a:fillRef>
-          <a:effectRef idx="1">
-            <a:schemeClr val="accent1"/>
-          </a:effectRef>
-          <a:fontRef idx="minor">
-            <a:schemeClr val="tx1"/>
-          </a:fontRef>
-        </p:style>
-      </p:cxnSp>
-      <p:sp>
-        <p:nvSpPr>
-          <p:cNvPr id="43" name="Rounded Rectangle 42"/>
-          <p:cNvSpPr/>
-          <p:nvPr/>
-        </p:nvSpPr>
-        <p:spPr>
-          <a:xfrm>
-            <a:off x="9626454" y="4443984"/>
-            <a:ext cx="1529225" cy="283464"/>
-          </a:xfrm>
-          <a:prstGeom prst="roundRect">
-            <a:avLst/>
-          </a:prstGeom>
-          <a:solidFill>
-            <a:srgbClr val="203A57"/>
-          </a:solidFill>
-          <a:ln>
-            <a:noFill/>
-          </a:ln>
-        </p:spPr>
-        <p:style>
-          <a:lnRef idx="1">
-            <a:schemeClr val="accent1"/>
-          </a:lnRef>
-          <a:fillRef idx="3">
-            <a:schemeClr val="accent1"/>
-          </a:fillRef>
-          <a:effectRef idx="2">
-            <a:schemeClr val="accent1"/>
-          </a:effectRef>
-          <a:fontRef idx="minor">
-            <a:schemeClr val="lt1"/>
-          </a:fontRef>
-        </p:style>
-        <p:txBody>
-          <a:bodyPr rtlCol="0" anchor="ctr"/>
-          <a:lstStyle/>
-          <a:p>
-            <a:pPr algn="ctr"/>
-          </a:p>
-        </p:txBody>
-      </p:sp>
-      <p:sp>
-        <p:nvSpPr>
-          <p:cNvPr id="44" name="TextBox 43"/>
-          <p:cNvSpPr txBox="1"/>
-          <p:nvPr/>
-        </p:nvSpPr>
-        <p:spPr>
-          <a:xfrm>
-            <a:off x="9672174" y="4517136"/>
-            <a:ext cx="1437785" cy="109728"/>
-          </a:xfrm>
-          <a:prstGeom prst="rect">
-            <a:avLst/>
-          </a:prstGeom>
-          <a:noFill/>
-        </p:spPr>
-        <p:txBody>
-          <a:bodyPr wrap="square" lIns="45720" rIns="45720" anchor="ctr">
-            <a:spAutoFit/>
-          </a:bodyPr>
-          <a:lstStyle/>
-          <a:p>
-            <a:pPr algn="ctr">
-              <a:lnSpc>
-                <a:spcPct val="100000"/>
-              </a:lnSpc>
-              <a:spcBef>
-                <a:spcPts val="0"/>
-              </a:spcBef>
-              <a:spcAft>
-                <a:spcPts val="0"/>
-              </a:spcAft>
-            </a:pPr>
-            <a:r>
-              <a:rPr sz="620" b="1" i="0">
-                <a:solidFill>
-                  <a:srgbClr val="FFFFFF"/>
-                </a:solidFill>
-                <a:latin typeface="Cascadia Mono"/>
-              </a:rPr>
-              <a:t>PLANNED</a:t>
-            </a:r>
-          </a:p>
-        </p:txBody>
-      </p:sp>
-      <p:cxnSp>
-        <p:nvCxnSpPr>
-          <p:cNvPr id="45" name="Connector 44"/>
-          <p:cNvCxnSpPr/>
-          <p:nvPr/>
-        </p:nvCxnSpPr>
-        <p:spPr>
-          <a:xfrm>
-            <a:off x="3815399" y="1719072"/>
-            <a:ext cx="0" cy="3685032"/>
-          </a:xfrm>
-          <a:prstGeom prst="line">
-            <a:avLst/>
-          </a:prstGeom>
-          <a:ln w="10160">
-            <a:solidFill>
-              <a:srgbClr val="8A3346"/>
-            </a:solidFill>
-          </a:ln>
-        </p:spPr>
-        <p:style>
-          <a:lnRef idx="2">
-            <a:schemeClr val="accent1"/>
-          </a:lnRef>
-          <a:fillRef idx="0">
-            <a:schemeClr val="accent1"/>
-          </a:fillRef>
-          <a:effectRef idx="1">
-            <a:schemeClr val="accent1"/>
-          </a:effectRef>
-          <a:fontRef idx="minor">
-            <a:schemeClr val="tx1"/>
-          </a:fontRef>
-        </p:style>
-      </p:cxnSp>
-      <p:sp>
-        <p:nvSpPr>
-          <p:cNvPr id="46" name="Oval 45"/>
-          <p:cNvSpPr/>
-          <p:nvPr/>
-        </p:nvSpPr>
-        <p:spPr>
-          <a:xfrm>
-            <a:off x="3765107" y="1755648"/>
-            <a:ext cx="100584" cy="100584"/>
-          </a:xfrm>
-          <a:prstGeom prst="ellipse">
-            <a:avLst/>
-          </a:prstGeom>
-          <a:solidFill>
-            <a:srgbClr val="8A3346"/>
-          </a:solidFill>
-          <a:ln>
-            <a:noFill/>
-          </a:ln>
-        </p:spPr>
-        <p:style>
-          <a:lnRef idx="1">
-            <a:schemeClr val="accent1"/>
-          </a:lnRef>
-          <a:fillRef idx="3">
-            <a:schemeClr val="accent1"/>
-          </a:fillRef>
-          <a:effectRef idx="2">
-            <a:schemeClr val="accent1"/>
-          </a:effectRef>
-          <a:fontRef idx="minor">
-            <a:schemeClr val="lt1"/>
-          </a:fontRef>
-        </p:style>
-        <p:txBody>
-          <a:bodyPr rtlCol="0" anchor="ctr"/>
-          <a:lstStyle/>
-          <a:p>
-            <a:pPr algn="ctr"/>
-          </a:p>
-        </p:txBody>
-      </p:sp>
-      <p:cxnSp>
-        <p:nvCxnSpPr>
-          <p:cNvPr id="47" name="Connector 46"/>
-          <p:cNvCxnSpPr/>
-          <p:nvPr/>
-        </p:nvCxnSpPr>
-        <p:spPr>
-          <a:xfrm>
-            <a:off x="7026772" y="1719072"/>
-            <a:ext cx="0" cy="3685032"/>
-          </a:xfrm>
-          <a:prstGeom prst="line">
-            <a:avLst/>
-          </a:prstGeom>
-          <a:ln w="10160">
-            <a:solidFill>
-              <a:srgbClr val="203A57"/>
-            </a:solidFill>
-          </a:ln>
-        </p:spPr>
-        <p:style>
-          <a:lnRef idx="2">
-            <a:schemeClr val="accent1"/>
-          </a:lnRef>
-          <a:fillRef idx="0">
-            <a:schemeClr val="accent1"/>
-          </a:fillRef>
-          <a:effectRef idx="1">
-            <a:schemeClr val="accent1"/>
-          </a:effectRef>
-          <a:fontRef idx="minor">
-            <a:schemeClr val="tx1"/>
-          </a:fontRef>
-        </p:style>
-      </p:cxnSp>
-      <p:sp>
-        <p:nvSpPr>
-          <p:cNvPr id="48" name="Oval 47"/>
-          <p:cNvSpPr/>
-          <p:nvPr/>
-        </p:nvSpPr>
-        <p:spPr>
-          <a:xfrm>
-            <a:off x="6976480" y="1755648"/>
-            <a:ext cx="100584" cy="100584"/>
-          </a:xfrm>
-          <a:prstGeom prst="ellipse">
-            <a:avLst/>
-          </a:prstGeom>
-          <a:solidFill>
-            <a:srgbClr val="203A57"/>
-          </a:solidFill>
-          <a:ln>
-            <a:noFill/>
-          </a:ln>
-        </p:spPr>
-        <p:style>
-          <a:lnRef idx="1">
-            <a:schemeClr val="accent1"/>
-          </a:lnRef>
-          <a:fillRef idx="3">
-            <a:schemeClr val="accent1"/>
-          </a:fillRef>
-          <a:effectRef idx="2">
-            <a:schemeClr val="accent1"/>
-          </a:effectRef>
-          <a:fontRef idx="minor">
-            <a:schemeClr val="lt1"/>
-          </a:fontRef>
-        </p:style>
-        <p:txBody>
-          <a:bodyPr rtlCol="0" anchor="ctr"/>
-          <a:lstStyle/>
-          <a:p>
-            <a:pPr algn="ctr"/>
-          </a:p>
-        </p:txBody>
-      </p:sp>
-      <p:cxnSp>
-        <p:nvCxnSpPr>
-          <p:cNvPr id="49" name="Connector 48"/>
-          <p:cNvCxnSpPr/>
-          <p:nvPr/>
-        </p:nvCxnSpPr>
-        <p:spPr>
-          <a:xfrm>
-            <a:off x="10773373" y="1719072"/>
-            <a:ext cx="0" cy="3685032"/>
-          </a:xfrm>
-          <a:prstGeom prst="line">
-            <a:avLst/>
-          </a:prstGeom>
-          <a:ln w="10160">
-            <a:solidFill>
-              <a:srgbClr val="203A57"/>
-            </a:solidFill>
-          </a:ln>
-        </p:spPr>
-        <p:style>
-          <a:lnRef idx="2">
-            <a:schemeClr val="accent1"/>
-          </a:lnRef>
-          <a:fillRef idx="0">
-            <a:schemeClr val="accent1"/>
-          </a:fillRef>
-          <a:effectRef idx="1">
-            <a:schemeClr val="accent1"/>
-          </a:effectRef>
-          <a:fontRef idx="minor">
-            <a:schemeClr val="tx1"/>
-          </a:fontRef>
-        </p:style>
-      </p:cxnSp>
-      <p:sp>
-        <p:nvSpPr>
-          <p:cNvPr id="50" name="Oval 49"/>
-          <p:cNvSpPr/>
-          <p:nvPr/>
-        </p:nvSpPr>
-        <p:spPr>
-          <a:xfrm>
-            <a:off x="10723081" y="1755648"/>
-            <a:ext cx="100584" cy="100584"/>
-          </a:xfrm>
-          <a:prstGeom prst="ellipse">
-            <a:avLst/>
-          </a:prstGeom>
-          <a:solidFill>
-            <a:srgbClr val="203A57"/>
-          </a:solidFill>
-          <a:ln>
-            <a:noFill/>
-          </a:ln>
-        </p:spPr>
-        <p:style>
-          <a:lnRef idx="1">
-            <a:schemeClr val="accent1"/>
-          </a:lnRef>
-          <a:fillRef idx="3">
-            <a:schemeClr val="accent1"/>
-          </a:fillRef>
-          <a:effectRef idx="2">
-            <a:schemeClr val="accent1"/>
-          </a:effectRef>
-          <a:fontRef idx="minor">
-            <a:schemeClr val="lt1"/>
-          </a:fontRef>
-        </p:style>
-        <p:txBody>
-          <a:bodyPr rtlCol="0" anchor="ctr"/>
-          <a:lstStyle/>
-          <a:p>
-            <a:pPr algn="ctr"/>
-          </a:p>
-        </p:txBody>
-      </p:sp>
-      <p:cxnSp>
-        <p:nvCxnSpPr>
-          <p:cNvPr id="51" name="Connector 50"/>
-          <p:cNvCxnSpPr/>
-          <p:nvPr/>
-        </p:nvCxnSpPr>
-        <p:spPr>
-          <a:xfrm>
-            <a:off x="11002757" y="1719072"/>
-            <a:ext cx="0" cy="3685032"/>
-          </a:xfrm>
-          <a:prstGeom prst="line">
-            <a:avLst/>
-          </a:prstGeom>
-          <a:ln w="10160">
-            <a:solidFill>
-              <a:srgbClr val="8A3346"/>
-            </a:solidFill>
-          </a:ln>
-        </p:spPr>
-        <p:style>
-          <a:lnRef idx="2">
-            <a:schemeClr val="accent1"/>
-          </a:lnRef>
-          <a:fillRef idx="0">
-            <a:schemeClr val="accent1"/>
-          </a:fillRef>
-          <a:effectRef idx="1">
-            <a:schemeClr val="accent1"/>
-          </a:effectRef>
-          <a:fontRef idx="minor">
-            <a:schemeClr val="tx1"/>
-          </a:fontRef>
-        </p:style>
-      </p:cxnSp>
-      <p:sp>
-        <p:nvSpPr>
-          <p:cNvPr id="52" name="Oval 51"/>
-          <p:cNvSpPr/>
-          <p:nvPr/>
-        </p:nvSpPr>
-        <p:spPr>
-          <a:xfrm>
-            <a:off x="10952465" y="1755648"/>
-            <a:ext cx="100584" cy="100584"/>
-          </a:xfrm>
-          <a:prstGeom prst="ellipse">
-            <a:avLst/>
-          </a:prstGeom>
-          <a:solidFill>
-            <a:srgbClr val="8A3346"/>
-          </a:solidFill>
-          <a:ln>
-            <a:noFill/>
-          </a:ln>
-        </p:spPr>
-        <p:style>
-          <a:lnRef idx="1">
-            <a:schemeClr val="accent1"/>
-          </a:lnRef>
-          <a:fillRef idx="3">
-            <a:schemeClr val="accent1"/>
-          </a:fillRef>
-          <a:effectRef idx="2">
-            <a:schemeClr val="accent1"/>
-          </a:effectRef>
-          <a:fontRef idx="minor">
-            <a:schemeClr val="lt1"/>
-          </a:fontRef>
-        </p:style>
-        <p:txBody>
-          <a:bodyPr rtlCol="0" anchor="ctr"/>
-          <a:lstStyle/>
-          <a:p>
-            <a:pPr algn="ctr"/>
-          </a:p>
-        </p:txBody>
-      </p:sp>
-      <p:sp>
-        <p:nvSpPr>
-          <p:cNvPr id="53" name="Rectangle 52"/>
-          <p:cNvSpPr/>
-          <p:nvPr/>
-        </p:nvSpPr>
-        <p:spPr>
-          <a:xfrm>
-            <a:off x="10161683" y="4407408"/>
-            <a:ext cx="535228" cy="356616"/>
-          </a:xfrm>
-          <a:prstGeom prst="rect">
-            <a:avLst/>
-          </a:prstGeom>
-          <a:noFill/>
-          <a:ln w="13970">
-            <a:solidFill>
-              <a:srgbClr val="8A3346"/>
-            </a:solidFill>
-          </a:ln>
-        </p:spPr>
-        <p:style>
-          <a:lnRef idx="1">
-            <a:schemeClr val="accent1"/>
-          </a:lnRef>
-          <a:fillRef idx="3">
-            <a:schemeClr val="accent1"/>
-          </a:fillRef>
-          <a:effectRef idx="2">
-            <a:schemeClr val="accent1"/>
-          </a:effectRef>
-          <a:fontRef idx="minor">
-            <a:schemeClr val="lt1"/>
-          </a:fontRef>
-        </p:style>
-        <p:txBody>
-          <a:bodyPr rtlCol="0" anchor="ctr"/>
-          <a:lstStyle/>
-          <a:p>
-            <a:pPr algn="ctr"/>
-          </a:p>
-        </p:txBody>
-      </p:sp>
-      <p:sp>
-        <p:nvSpPr>
-          <p:cNvPr id="54" name="TextBox 53"/>
-          <p:cNvSpPr txBox="1"/>
-          <p:nvPr/>
-        </p:nvSpPr>
-        <p:spPr>
-          <a:xfrm>
-            <a:off x="10161683" y="4791456"/>
-            <a:ext cx="535228" cy="128016"/>
-          </a:xfrm>
-          <a:prstGeom prst="rect">
-            <a:avLst/>
-          </a:prstGeom>
-          <a:noFill/>
-        </p:spPr>
-        <p:txBody>
-          <a:bodyPr wrap="square" lIns="45720" rIns="45720" anchor="t">
-            <a:spAutoFit/>
-          </a:bodyPr>
-          <a:lstStyle/>
-          <a:p>
-            <a:pPr algn="ctr">
-              <a:lnSpc>
-                <a:spcPct val="100000"/>
-              </a:lnSpc>
-              <a:spcBef>
-                <a:spcPts val="0"/>
-              </a:spcBef>
-              <a:spcAft>
-                <a:spcPts val="0"/>
-              </a:spcAft>
-            </a:pPr>
-            <a:r>
-              <a:rPr sz="610" b="0" i="0">
-                <a:solidFill>
-                  <a:srgbClr val="8A3346"/>
-                </a:solidFill>
-                <a:latin typeface="Cascadia Mono"/>
-              </a:rPr>
               <a:t>W16 contingency</a:t>
             </a:r>
           </a:p>
@@ -25149,7 +25485,7 @@
       </p:sp>
       <p:sp>
         <p:nvSpPr>
-          <p:cNvPr id="55" name="Rounded Rectangle 54"/>
+          <p:cNvPr id="60" name="Rounded Rectangle 59"/>
           <p:cNvSpPr/>
           <p:nvPr/>
         </p:nvSpPr>
@@ -25194,7 +25530,7 @@
       </p:sp>
       <p:sp>
         <p:nvSpPr>
-          <p:cNvPr id="56" name="TextBox 55"/>
+          <p:cNvPr id="61" name="TextBox 60"/>
           <p:cNvSpPr txBox="1"/>
           <p:nvPr/>
         </p:nvSpPr>
@@ -25239,7 +25575,7 @@
       </p:sp>
       <p:sp>
         <p:nvSpPr>
-          <p:cNvPr id="57" name="TextBox 56"/>
+          <p:cNvPr id="62" name="TextBox 61"/>
           <p:cNvSpPr txBox="1"/>
           <p:nvPr/>
         </p:nvSpPr>
@@ -25277,14 +25613,14 @@
                 </a:solidFill>
                 <a:latin typeface="Georgia"/>
               </a:rPr>
-              <a:t>Only BLER characterization is in progress; all later work is planned.</a:t>
+              <a:t>G8_C and G8_D are complete. G8_E/E0 is next but not started; all later work remains planned.</a:t>
             </a:r>
           </a:p>
         </p:txBody>
       </p:sp>
       <p:cxnSp>
         <p:nvCxnSpPr>
-          <p:cNvPr id="58" name="Connector 57"/>
+          <p:cNvPr id="63" name="Connector 62"/>
           <p:cNvCxnSpPr/>
           <p:nvPr/>
         </p:nvCxnSpPr>
@@ -25319,7 +25655,7 @@
       </p:cxnSp>
       <p:sp>
         <p:nvSpPr>
-          <p:cNvPr id="59" name="Rounded Rectangle 58"/>
+          <p:cNvPr id="64" name="Rounded Rectangle 63"/>
           <p:cNvSpPr/>
           <p:nvPr/>
         </p:nvSpPr>
@@ -25362,7 +25698,7 @@
       </p:sp>
       <p:sp>
         <p:nvSpPr>
-          <p:cNvPr id="60" name="TextBox 59"/>
+          <p:cNvPr id="65" name="TextBox 64"/>
           <p:cNvSpPr txBox="1"/>
           <p:nvPr/>
         </p:nvSpPr>
@@ -25407,7 +25743,7 @@
       </p:sp>
       <p:sp>
         <p:nvSpPr>
-          <p:cNvPr id="61" name="TextBox 60"/>
+          <p:cNvPr id="66" name="TextBox 65"/>
           <p:cNvSpPr txBox="1"/>
           <p:nvPr/>
         </p:nvSpPr>
@@ -25452,7 +25788,7 @@
       </p:sp>
       <p:sp>
         <p:nvSpPr>
-          <p:cNvPr id="62" name="TextBox 61"/>
+          <p:cNvPr id="67" name="TextBox 66"/>
           <p:cNvSpPr txBox="1"/>
           <p:nvPr/>
         </p:nvSpPr>

</xml_diff>

<commit_message>
docs(review-1): correct G8 phase ordering
</commit_message>
<xml_diff>
--- a/deliverables/review-1/semantic-communication-first-review-academic-v2.pptx
+++ b/deliverables/review-1/semantic-communication-first-review-academic-v2.pptx
@@ -23438,7 +23438,7 @@
         <p:spPr>
           <a:xfrm>
             <a:off x="3127248" y="1719072"/>
-            <a:ext cx="0" cy="3858768"/>
+            <a:ext cx="0" cy="3236976"/>
           </a:xfrm>
           <a:prstGeom prst="line">
             <a:avLst/>
@@ -23563,7 +23563,7 @@
         <p:spPr>
           <a:xfrm>
             <a:off x="4885856" y="1719072"/>
-            <a:ext cx="0" cy="3858768"/>
+            <a:ext cx="0" cy="3236976"/>
           </a:xfrm>
           <a:prstGeom prst="line">
             <a:avLst/>
@@ -23688,7 +23688,7 @@
         <p:spPr>
           <a:xfrm>
             <a:off x="7179694" y="1719072"/>
-            <a:ext cx="0" cy="3858768"/>
+            <a:ext cx="0" cy="3236976"/>
           </a:xfrm>
           <a:prstGeom prst="line">
             <a:avLst/>
@@ -23813,7 +23813,7 @@
         <p:spPr>
           <a:xfrm>
             <a:off x="9549993" y="1719072"/>
-            <a:ext cx="0" cy="3858768"/>
+            <a:ext cx="0" cy="3236976"/>
           </a:xfrm>
           <a:prstGeom prst="line">
             <a:avLst/>
@@ -23848,7 +23848,7 @@
         <p:spPr>
           <a:xfrm>
             <a:off x="11155680" y="1719072"/>
-            <a:ext cx="0" cy="3858768"/>
+            <a:ext cx="0" cy="3236976"/>
           </a:xfrm>
           <a:prstGeom prst="line">
             <a:avLst/>
@@ -23882,8 +23882,8 @@
         </p:nvSpPr>
         <p:spPr>
           <a:xfrm>
-            <a:off x="731520" y="2011679"/>
-            <a:ext cx="2176272" cy="228600"/>
+            <a:off x="731520" y="1874519"/>
+            <a:ext cx="2176272" cy="201168"/>
           </a:xfrm>
           <a:prstGeom prst="rect">
             <a:avLst/>
@@ -23908,7 +23908,7 @@
               </a:spcAft>
             </a:pPr>
             <a:r>
-              <a:rPr sz="940" b="0" i="0">
+              <a:rPr sz="869" b="0" i="0">
                 <a:solidFill>
                   <a:srgbClr val="18212B"/>
                 </a:solidFill>
@@ -23927,7 +23927,7 @@
         </p:nvCxnSpPr>
         <p:spPr>
           <a:xfrm>
-            <a:off x="713232" y="2340864"/>
+            <a:off x="713232" y="2148840"/>
             <a:ext cx="10442448" cy="0"/>
           </a:xfrm>
           <a:prstGeom prst="line">
@@ -23962,8 +23962,8 @@
         </p:nvSpPr>
         <p:spPr>
           <a:xfrm>
-            <a:off x="3127248" y="2020824"/>
-            <a:ext cx="458767" cy="283464"/>
+            <a:off x="3127248" y="1874519"/>
+            <a:ext cx="458767" cy="256032"/>
           </a:xfrm>
           <a:prstGeom prst="roundRect">
             <a:avLst/>
@@ -24005,8 +24005,8 @@
         </p:nvSpPr>
         <p:spPr>
           <a:xfrm>
-            <a:off x="731520" y="2432303"/>
-            <a:ext cx="2176272" cy="228600"/>
+            <a:off x="731520" y="2221991"/>
+            <a:ext cx="2176272" cy="201168"/>
           </a:xfrm>
           <a:prstGeom prst="rect">
             <a:avLst/>
@@ -24031,7 +24031,7 @@
               </a:spcAft>
             </a:pPr>
             <a:r>
-              <a:rPr sz="940" b="0" i="0">
+              <a:rPr sz="869" b="0" i="0">
                 <a:solidFill>
                   <a:srgbClr val="18212B"/>
                 </a:solidFill>
@@ -24050,7 +24050,7 @@
         </p:nvCxnSpPr>
         <p:spPr>
           <a:xfrm>
-            <a:off x="713232" y="2761488"/>
+            <a:off x="713232" y="2496312"/>
             <a:ext cx="10442448" cy="0"/>
           </a:xfrm>
           <a:prstGeom prst="line">
@@ -24085,8 +24085,8 @@
         </p:nvSpPr>
         <p:spPr>
           <a:xfrm>
-            <a:off x="3586015" y="2441448"/>
-            <a:ext cx="229383" cy="283464"/>
+            <a:off x="3586015" y="2221991"/>
+            <a:ext cx="229383" cy="256032"/>
           </a:xfrm>
           <a:prstGeom prst="roundRect">
             <a:avLst/>
@@ -24128,8 +24128,8 @@
         </p:nvSpPr>
         <p:spPr>
           <a:xfrm>
-            <a:off x="731520" y="2852927"/>
-            <a:ext cx="2176272" cy="228600"/>
+            <a:off x="731520" y="2569463"/>
+            <a:ext cx="2176272" cy="201168"/>
           </a:xfrm>
           <a:prstGeom prst="rect">
             <a:avLst/>
@@ -24154,13 +24154,13 @@
               </a:spcAft>
             </a:pPr>
             <a:r>
-              <a:rPr sz="940" b="0" i="0">
+              <a:rPr sz="869" b="0" i="0">
                 <a:solidFill>
                   <a:srgbClr val="18212B"/>
                 </a:solidFill>
                 <a:latin typeface="Arial"/>
               </a:rPr>
-              <a:t>G8_E validation + pass one / G-8</a:t>
+              <a:t>G8_E validation + initial selection</a:t>
             </a:r>
           </a:p>
         </p:txBody>
@@ -24173,7 +24173,7 @@
         </p:nvCxnSpPr>
         <p:spPr>
           <a:xfrm>
-            <a:off x="713232" y="3182112"/>
+            <a:off x="713232" y="2843784"/>
             <a:ext cx="10442448" cy="0"/>
           </a:xfrm>
           <a:prstGeom prst="line">
@@ -24208,8 +24208,8 @@
         </p:nvSpPr>
         <p:spPr>
           <a:xfrm>
-            <a:off x="3815399" y="2862072"/>
-            <a:ext cx="382306" cy="283464"/>
+            <a:off x="3815399" y="2569463"/>
+            <a:ext cx="305845" cy="256032"/>
           </a:xfrm>
           <a:prstGeom prst="roundRect">
             <a:avLst/>
@@ -24251,8 +24251,8 @@
         </p:nvSpPr>
         <p:spPr>
           <a:xfrm>
-            <a:off x="731520" y="3273551"/>
-            <a:ext cx="2176272" cy="228600"/>
+            <a:off x="731520" y="2916936"/>
+            <a:ext cx="2176272" cy="201168"/>
           </a:xfrm>
           <a:prstGeom prst="rect">
             <a:avLst/>
@@ -24277,13 +24277,13 @@
               </a:spcAft>
             </a:pPr>
             <a:r>
-              <a:rPr sz="940" b="0" i="0">
+              <a:rPr sz="869" b="0" i="0">
                 <a:solidFill>
                   <a:srgbClr val="18212B"/>
                 </a:solidFill>
                 <a:latin typeface="Arial"/>
               </a:rPr>
-              <a:t>Learned model training + tuning</a:t>
+              <a:t>G8_F artifact classifier + pass two</a:t>
             </a:r>
           </a:p>
         </p:txBody>
@@ -24296,7 +24296,7 @@
         </p:nvCxnSpPr>
         <p:spPr>
           <a:xfrm>
-            <a:off x="713232" y="3602736"/>
+            <a:off x="713232" y="3191256"/>
             <a:ext cx="10442448" cy="0"/>
           </a:xfrm>
           <a:prstGeom prst="line">
@@ -24331,8 +24331,254 @@
         </p:nvSpPr>
         <p:spPr>
           <a:xfrm>
-            <a:off x="4274166" y="3282696"/>
-            <a:ext cx="2140915" cy="283464"/>
+            <a:off x="4121244" y="2916936"/>
+            <a:ext cx="305845" cy="256032"/>
+          </a:xfrm>
+          <a:prstGeom prst="roundRect">
+            <a:avLst/>
+          </a:prstGeom>
+          <a:solidFill>
+            <a:srgbClr val="D9D9D9"/>
+          </a:solidFill>
+          <a:ln>
+            <a:noFill/>
+          </a:ln>
+        </p:spPr>
+        <p:style>
+          <a:lnRef idx="1">
+            <a:schemeClr val="accent1"/>
+          </a:lnRef>
+          <a:fillRef idx="3">
+            <a:schemeClr val="accent1"/>
+          </a:fillRef>
+          <a:effectRef idx="2">
+            <a:schemeClr val="accent1"/>
+          </a:effectRef>
+          <a:fontRef idx="minor">
+            <a:schemeClr val="lt1"/>
+          </a:fontRef>
+        </p:style>
+        <p:txBody>
+          <a:bodyPr rtlCol="0" anchor="ctr"/>
+          <a:lstStyle/>
+          <a:p>
+            <a:pPr algn="ctr"/>
+          </a:p>
+        </p:txBody>
+      </p:sp>
+      <p:sp>
+        <p:nvSpPr>
+          <p:cNvPr id="33" name="TextBox 32"/>
+          <p:cNvSpPr txBox="1"/>
+          <p:nvPr/>
+        </p:nvSpPr>
+        <p:spPr>
+          <a:xfrm>
+            <a:off x="731520" y="3264408"/>
+            <a:ext cx="2176272" cy="201168"/>
+          </a:xfrm>
+          <a:prstGeom prst="rect">
+            <a:avLst/>
+          </a:prstGeom>
+          <a:noFill/>
+        </p:spPr>
+        <p:txBody>
+          <a:bodyPr wrap="square" lIns="45720" rIns="45720" anchor="ctr">
+            <a:spAutoFit/>
+          </a:bodyPr>
+          <a:lstStyle/>
+          <a:p>
+            <a:pPr algn="l">
+              <a:lnSpc>
+                <a:spcPct val="100000"/>
+              </a:lnSpc>
+              <a:spcBef>
+                <a:spcPts val="0"/>
+              </a:spcBef>
+              <a:spcAft>
+                <a:spcPts val="0"/>
+              </a:spcAft>
+            </a:pPr>
+            <a:r>
+              <a:rPr sz="869" b="0" i="0">
+                <a:solidFill>
+                  <a:srgbClr val="18212B"/>
+                </a:solidFill>
+                <a:latin typeface="Arial"/>
+              </a:rPr>
+              <a:t>G8_G final G-8 ratio/adjudication</a:t>
+            </a:r>
+          </a:p>
+        </p:txBody>
+      </p:sp>
+      <p:cxnSp>
+        <p:nvCxnSpPr>
+          <p:cNvPr id="34" name="Connector 33"/>
+          <p:cNvCxnSpPr/>
+          <p:nvPr/>
+        </p:nvCxnSpPr>
+        <p:spPr>
+          <a:xfrm>
+            <a:off x="713232" y="3538728"/>
+            <a:ext cx="10442448" cy="0"/>
+          </a:xfrm>
+          <a:prstGeom prst="line">
+            <a:avLst/>
+          </a:prstGeom>
+          <a:ln w="4445">
+            <a:solidFill>
+              <a:srgbClr val="D7D2C8"/>
+            </a:solidFill>
+          </a:ln>
+        </p:spPr>
+        <p:style>
+          <a:lnRef idx="2">
+            <a:schemeClr val="accent1"/>
+          </a:lnRef>
+          <a:fillRef idx="0">
+            <a:schemeClr val="accent1"/>
+          </a:fillRef>
+          <a:effectRef idx="1">
+            <a:schemeClr val="accent1"/>
+          </a:effectRef>
+          <a:fontRef idx="minor">
+            <a:schemeClr val="tx1"/>
+          </a:fontRef>
+        </p:style>
+      </p:cxnSp>
+      <p:sp>
+        <p:nvSpPr>
+          <p:cNvPr id="35" name="Rounded Rectangle 34"/>
+          <p:cNvSpPr/>
+          <p:nvPr/>
+        </p:nvSpPr>
+        <p:spPr>
+          <a:xfrm>
+            <a:off x="4427089" y="3264408"/>
+            <a:ext cx="164592" cy="256032"/>
+          </a:xfrm>
+          <a:prstGeom prst="roundRect">
+            <a:avLst/>
+          </a:prstGeom>
+          <a:solidFill>
+            <a:srgbClr val="D9D9D9"/>
+          </a:solidFill>
+          <a:ln>
+            <a:noFill/>
+          </a:ln>
+        </p:spPr>
+        <p:style>
+          <a:lnRef idx="1">
+            <a:schemeClr val="accent1"/>
+          </a:lnRef>
+          <a:fillRef idx="3">
+            <a:schemeClr val="accent1"/>
+          </a:fillRef>
+          <a:effectRef idx="2">
+            <a:schemeClr val="accent1"/>
+          </a:effectRef>
+          <a:fontRef idx="minor">
+            <a:schemeClr val="lt1"/>
+          </a:fontRef>
+        </p:style>
+        <p:txBody>
+          <a:bodyPr rtlCol="0" anchor="ctr"/>
+          <a:lstStyle/>
+          <a:p>
+            <a:pPr algn="ctr"/>
+          </a:p>
+        </p:txBody>
+      </p:sp>
+      <p:sp>
+        <p:nvSpPr>
+          <p:cNvPr id="36" name="TextBox 35"/>
+          <p:cNvSpPr txBox="1"/>
+          <p:nvPr/>
+        </p:nvSpPr>
+        <p:spPr>
+          <a:xfrm>
+            <a:off x="731520" y="3611879"/>
+            <a:ext cx="2176272" cy="201168"/>
+          </a:xfrm>
+          <a:prstGeom prst="rect">
+            <a:avLst/>
+          </a:prstGeom>
+          <a:noFill/>
+        </p:spPr>
+        <p:txBody>
+          <a:bodyPr wrap="square" lIns="45720" rIns="45720" anchor="ctr">
+            <a:spAutoFit/>
+          </a:bodyPr>
+          <a:lstStyle/>
+          <a:p>
+            <a:pPr algn="l">
+              <a:lnSpc>
+                <a:spcPct val="100000"/>
+              </a:lnSpc>
+              <a:spcBef>
+                <a:spcPts val="0"/>
+              </a:spcBef>
+              <a:spcAft>
+                <a:spcPts val="0"/>
+              </a:spcAft>
+            </a:pPr>
+            <a:r>
+              <a:rPr sz="869" b="0" i="0">
+                <a:solidFill>
+                  <a:srgbClr val="18212B"/>
+                </a:solidFill>
+                <a:latin typeface="Arial"/>
+              </a:rPr>
+              <a:t>Learned-system training + calibration</a:t>
+            </a:r>
+          </a:p>
+        </p:txBody>
+      </p:sp>
+      <p:cxnSp>
+        <p:nvCxnSpPr>
+          <p:cNvPr id="37" name="Connector 36"/>
+          <p:cNvCxnSpPr/>
+          <p:nvPr/>
+        </p:nvCxnSpPr>
+        <p:spPr>
+          <a:xfrm>
+            <a:off x="713232" y="3886200"/>
+            <a:ext cx="10442448" cy="0"/>
+          </a:xfrm>
+          <a:prstGeom prst="line">
+            <a:avLst/>
+          </a:prstGeom>
+          <a:ln w="4445">
+            <a:solidFill>
+              <a:srgbClr val="D7D2C8"/>
+            </a:solidFill>
+          </a:ln>
+        </p:spPr>
+        <p:style>
+          <a:lnRef idx="2">
+            <a:schemeClr val="accent1"/>
+          </a:lnRef>
+          <a:fillRef idx="0">
+            <a:schemeClr val="accent1"/>
+          </a:fillRef>
+          <a:effectRef idx="1">
+            <a:schemeClr val="accent1"/>
+          </a:effectRef>
+          <a:fontRef idx="minor">
+            <a:schemeClr val="tx1"/>
+          </a:fontRef>
+        </p:style>
+      </p:cxnSp>
+      <p:sp>
+        <p:nvSpPr>
+          <p:cNvPr id="38" name="Rounded Rectangle 37"/>
+          <p:cNvSpPr/>
+          <p:nvPr/>
+        </p:nvSpPr>
+        <p:spPr>
+          <a:xfrm>
+            <a:off x="4580011" y="3611879"/>
+            <a:ext cx="1605686" cy="256032"/>
           </a:xfrm>
           <a:prstGeom prst="roundRect">
             <a:avLst/>
@@ -24368,14 +24614,14 @@
       </p:sp>
       <p:sp>
         <p:nvSpPr>
-          <p:cNvPr id="33" name="TextBox 32"/>
-          <p:cNvSpPr txBox="1"/>
-          <p:nvPr/>
-        </p:nvSpPr>
-        <p:spPr>
-          <a:xfrm>
-            <a:off x="4319886" y="3355848"/>
-            <a:ext cx="2049475" cy="109728"/>
+          <p:cNvPr id="39" name="TextBox 38"/>
+          <p:cNvSpPr txBox="1"/>
+          <p:nvPr/>
+        </p:nvSpPr>
+        <p:spPr>
+          <a:xfrm>
+            <a:off x="4625731" y="3675887"/>
+            <a:ext cx="1514246" cy="91440"/>
           </a:xfrm>
           <a:prstGeom prst="rect">
             <a:avLst/>
@@ -24400,7 +24646,7 @@
               </a:spcAft>
             </a:pPr>
             <a:r>
-              <a:rPr sz="620" b="1" i="0">
+              <a:rPr sz="580" b="1" i="0">
                 <a:solidFill>
                   <a:srgbClr val="FFFFFF"/>
                 </a:solidFill>
@@ -24413,14 +24659,14 @@
       </p:sp>
       <p:sp>
         <p:nvSpPr>
-          <p:cNvPr id="34" name="TextBox 33"/>
-          <p:cNvSpPr txBox="1"/>
-          <p:nvPr/>
-        </p:nvSpPr>
-        <p:spPr>
-          <a:xfrm>
-            <a:off x="731520" y="3694176"/>
-            <a:ext cx="2176272" cy="228600"/>
+          <p:cNvPr id="40" name="TextBox 39"/>
+          <p:cNvSpPr txBox="1"/>
+          <p:nvPr/>
+        </p:nvSpPr>
+        <p:spPr>
+          <a:xfrm>
+            <a:off x="731520" y="3959352"/>
+            <a:ext cx="2176272" cy="201168"/>
           </a:xfrm>
           <a:prstGeom prst="rect">
             <a:avLst/>
@@ -24445,26 +24691,26 @@
               </a:spcAft>
             </a:pPr>
             <a:r>
-              <a:rPr sz="940" b="0" i="0">
+              <a:rPr sz="869" b="0" i="0">
                 <a:solidFill>
                   <a:srgbClr val="18212B"/>
                 </a:solidFill>
                 <a:latin typeface="Arial"/>
               </a:rPr>
-              <a:t>Digital feature system + validation</a:t>
+              <a:t>Validation, freeze + test campaign</a:t>
             </a:r>
           </a:p>
         </p:txBody>
       </p:sp>
       <p:cxnSp>
         <p:nvCxnSpPr>
-          <p:cNvPr id="35" name="Connector 34"/>
+          <p:cNvPr id="41" name="Connector 40"/>
           <p:cNvCxnSpPr/>
           <p:nvPr/>
         </p:nvCxnSpPr>
         <p:spPr>
           <a:xfrm>
-            <a:off x="713232" y="4023359"/>
+            <a:off x="713232" y="4233672"/>
             <a:ext cx="10442448" cy="0"/>
           </a:xfrm>
           <a:prstGeom prst="line">
@@ -24493,14 +24739,14 @@
       </p:cxnSp>
       <p:sp>
         <p:nvSpPr>
-          <p:cNvPr id="36" name="Rounded Rectangle 35"/>
+          <p:cNvPr id="42" name="Rounded Rectangle 41"/>
           <p:cNvSpPr/>
           <p:nvPr/>
         </p:nvSpPr>
         <p:spPr>
           <a:xfrm>
-            <a:off x="6415082" y="3703320"/>
-            <a:ext cx="1070457" cy="283464"/>
+            <a:off x="6185698" y="3959352"/>
+            <a:ext cx="2140915" cy="256032"/>
           </a:xfrm>
           <a:prstGeom prst="roundRect">
             <a:avLst/>
@@ -24536,14 +24782,14 @@
       </p:sp>
       <p:sp>
         <p:nvSpPr>
-          <p:cNvPr id="37" name="TextBox 36"/>
-          <p:cNvSpPr txBox="1"/>
-          <p:nvPr/>
-        </p:nvSpPr>
-        <p:spPr>
-          <a:xfrm>
-            <a:off x="6460802" y="3776472"/>
-            <a:ext cx="979017" cy="109728"/>
+          <p:cNvPr id="43" name="TextBox 42"/>
+          <p:cNvSpPr txBox="1"/>
+          <p:nvPr/>
+        </p:nvSpPr>
+        <p:spPr>
+          <a:xfrm>
+            <a:off x="6231418" y="4023360"/>
+            <a:ext cx="2049475" cy="91440"/>
           </a:xfrm>
           <a:prstGeom prst="rect">
             <a:avLst/>
@@ -24568,7 +24814,7 @@
               </a:spcAft>
             </a:pPr>
             <a:r>
-              <a:rPr sz="620" b="1" i="0">
+              <a:rPr sz="580" b="1" i="0">
                 <a:solidFill>
                   <a:srgbClr val="FFFFFF"/>
                 </a:solidFill>
@@ -24581,14 +24827,14 @@
       </p:sp>
       <p:sp>
         <p:nvSpPr>
-          <p:cNvPr id="38" name="TextBox 37"/>
-          <p:cNvSpPr txBox="1"/>
-          <p:nvPr/>
-        </p:nvSpPr>
-        <p:spPr>
-          <a:xfrm>
-            <a:off x="731520" y="4114800"/>
-            <a:ext cx="2176272" cy="228600"/>
+          <p:cNvPr id="44" name="TextBox 43"/>
+          <p:cNvSpPr txBox="1"/>
+          <p:nvPr/>
+        </p:nvSpPr>
+        <p:spPr>
+          <a:xfrm>
+            <a:off x="731520" y="4306824"/>
+            <a:ext cx="2176272" cy="201168"/>
           </a:xfrm>
           <a:prstGeom prst="rect">
             <a:avLst/>
@@ -24613,26 +24859,26 @@
               </a:spcAft>
             </a:pPr>
             <a:r>
-              <a:rPr sz="940" b="0" i="0">
+              <a:rPr sz="869" b="0" i="0">
                 <a:solidFill>
                   <a:srgbClr val="18212B"/>
                 </a:solidFill>
                 <a:latin typeface="Arial"/>
               </a:rPr>
-              <a:t>Freeze + single test campaign</a:t>
+              <a:t>Demo + optional replay</a:t>
             </a:r>
           </a:p>
         </p:txBody>
       </p:sp>
       <p:cxnSp>
         <p:nvCxnSpPr>
-          <p:cNvPr id="39" name="Connector 38"/>
+          <p:cNvPr id="45" name="Connector 44"/>
           <p:cNvCxnSpPr/>
           <p:nvPr/>
         </p:nvCxnSpPr>
         <p:spPr>
           <a:xfrm>
-            <a:off x="713232" y="4443983"/>
+            <a:off x="713232" y="4581144"/>
             <a:ext cx="10442448" cy="0"/>
           </a:xfrm>
           <a:prstGeom prst="line">
@@ -24661,14 +24907,14 @@
       </p:cxnSp>
       <p:sp>
         <p:nvSpPr>
-          <p:cNvPr id="40" name="Rounded Rectangle 39"/>
+          <p:cNvPr id="46" name="Rounded Rectangle 45"/>
           <p:cNvSpPr/>
           <p:nvPr/>
         </p:nvSpPr>
         <p:spPr>
           <a:xfrm>
-            <a:off x="7485539" y="4123944"/>
-            <a:ext cx="1070457" cy="283464"/>
+            <a:off x="8326613" y="4306824"/>
+            <a:ext cx="1299841" cy="256032"/>
           </a:xfrm>
           <a:prstGeom prst="roundRect">
             <a:avLst/>
@@ -24704,14 +24950,14 @@
       </p:sp>
       <p:sp>
         <p:nvSpPr>
-          <p:cNvPr id="41" name="TextBox 40"/>
-          <p:cNvSpPr txBox="1"/>
-          <p:nvPr/>
-        </p:nvSpPr>
-        <p:spPr>
-          <a:xfrm>
-            <a:off x="7531259" y="4197096"/>
-            <a:ext cx="979017" cy="109728"/>
+          <p:cNvPr id="47" name="TextBox 46"/>
+          <p:cNvSpPr txBox="1"/>
+          <p:nvPr/>
+        </p:nvSpPr>
+        <p:spPr>
+          <a:xfrm>
+            <a:off x="8372333" y="4370832"/>
+            <a:ext cx="1208401" cy="91440"/>
           </a:xfrm>
           <a:prstGeom prst="rect">
             <a:avLst/>
@@ -24736,7 +24982,7 @@
               </a:spcAft>
             </a:pPr>
             <a:r>
-              <a:rPr sz="620" b="1" i="0">
+              <a:rPr sz="580" b="1" i="0">
                 <a:solidFill>
                   <a:srgbClr val="FFFFFF"/>
                 </a:solidFill>
@@ -24749,14 +24995,14 @@
       </p:sp>
       <p:sp>
         <p:nvSpPr>
-          <p:cNvPr id="42" name="TextBox 41"/>
-          <p:cNvSpPr txBox="1"/>
-          <p:nvPr/>
-        </p:nvSpPr>
-        <p:spPr>
-          <a:xfrm>
-            <a:off x="731520" y="4535424"/>
-            <a:ext cx="2176272" cy="228600"/>
+          <p:cNvPr id="48" name="TextBox 47"/>
+          <p:cNvSpPr txBox="1"/>
+          <p:nvPr/>
+        </p:nvSpPr>
+        <p:spPr>
+          <a:xfrm>
+            <a:off x="731520" y="4654296"/>
+            <a:ext cx="2176272" cy="201168"/>
           </a:xfrm>
           <a:prstGeom prst="rect">
             <a:avLst/>
@@ -24781,26 +25027,26 @@
               </a:spcAft>
             </a:pPr>
             <a:r>
-              <a:rPr sz="940" b="0" i="0">
+              <a:rPr sz="869" b="0" i="0">
                 <a:solidFill>
                   <a:srgbClr val="18212B"/>
                 </a:solidFill>
                 <a:latin typeface="Arial"/>
               </a:rPr>
-              <a:t>Demo + optional replay</a:t>
+              <a:t>Report, audit + final review</a:t>
             </a:r>
           </a:p>
         </p:txBody>
       </p:sp>
       <p:cxnSp>
         <p:nvCxnSpPr>
-          <p:cNvPr id="43" name="Connector 42"/>
+          <p:cNvPr id="49" name="Connector 48"/>
           <p:cNvCxnSpPr/>
           <p:nvPr/>
         </p:nvCxnSpPr>
         <p:spPr>
           <a:xfrm>
-            <a:off x="713232" y="4864608"/>
+            <a:off x="713232" y="4928616"/>
             <a:ext cx="10442448" cy="0"/>
           </a:xfrm>
           <a:prstGeom prst="line">
@@ -24829,20 +25075,20 @@
       </p:cxnSp>
       <p:sp>
         <p:nvSpPr>
-          <p:cNvPr id="44" name="Rounded Rectangle 43"/>
+          <p:cNvPr id="50" name="Rounded Rectangle 49"/>
           <p:cNvSpPr/>
           <p:nvPr/>
         </p:nvSpPr>
         <p:spPr>
           <a:xfrm>
-            <a:off x="8555997" y="4544568"/>
-            <a:ext cx="1070457" cy="283464"/>
+            <a:off x="9626454" y="4654296"/>
+            <a:ext cx="1529225" cy="256032"/>
           </a:xfrm>
           <a:prstGeom prst="roundRect">
             <a:avLst/>
           </a:prstGeom>
           <a:solidFill>
-            <a:srgbClr val="A46A28"/>
+            <a:srgbClr val="203A57"/>
           </a:solidFill>
           <a:ln>
             <a:noFill/>
@@ -24872,14 +25118,14 @@
       </p:sp>
       <p:sp>
         <p:nvSpPr>
-          <p:cNvPr id="45" name="TextBox 44"/>
-          <p:cNvSpPr txBox="1"/>
-          <p:nvPr/>
-        </p:nvSpPr>
-        <p:spPr>
-          <a:xfrm>
-            <a:off x="8601717" y="4617720"/>
-            <a:ext cx="979017" cy="109728"/>
+          <p:cNvPr id="51" name="TextBox 50"/>
+          <p:cNvSpPr txBox="1"/>
+          <p:nvPr/>
+        </p:nvSpPr>
+        <p:spPr>
+          <a:xfrm>
+            <a:off x="9672174" y="4718304"/>
+            <a:ext cx="1437785" cy="91440"/>
           </a:xfrm>
           <a:prstGeom prst="rect">
             <a:avLst/>
@@ -24904,79 +25150,34 @@
               </a:spcAft>
             </a:pPr>
             <a:r>
-              <a:rPr sz="620" b="1" i="0">
+              <a:rPr sz="580" b="1" i="0">
                 <a:solidFill>
                   <a:srgbClr val="FFFFFF"/>
                 </a:solidFill>
                 <a:latin typeface="Cascadia Mono"/>
               </a:rPr>
               <a:t>PLANNED</a:t>
-            </a:r>
-          </a:p>
-        </p:txBody>
-      </p:sp>
-      <p:sp>
-        <p:nvSpPr>
-          <p:cNvPr id="46" name="TextBox 45"/>
-          <p:cNvSpPr txBox="1"/>
-          <p:nvPr/>
-        </p:nvSpPr>
-        <p:spPr>
-          <a:xfrm>
-            <a:off x="731520" y="4956048"/>
-            <a:ext cx="2176272" cy="228600"/>
-          </a:xfrm>
-          <a:prstGeom prst="rect">
-            <a:avLst/>
-          </a:prstGeom>
-          <a:noFill/>
-        </p:spPr>
-        <p:txBody>
-          <a:bodyPr wrap="square" lIns="45720" rIns="45720" anchor="ctr">
-            <a:spAutoFit/>
-          </a:bodyPr>
-          <a:lstStyle/>
-          <a:p>
-            <a:pPr algn="l">
-              <a:lnSpc>
-                <a:spcPct val="100000"/>
-              </a:lnSpc>
-              <a:spcBef>
-                <a:spcPts val="0"/>
-              </a:spcBef>
-              <a:spcAft>
-                <a:spcPts val="0"/>
-              </a:spcAft>
-            </a:pPr>
-            <a:r>
-              <a:rPr sz="940" b="0" i="0">
-                <a:solidFill>
-                  <a:srgbClr val="18212B"/>
-                </a:solidFill>
-                <a:latin typeface="Arial"/>
-              </a:rPr>
-              <a:t>Report, audit + final review</a:t>
             </a:r>
           </a:p>
         </p:txBody>
       </p:sp>
       <p:cxnSp>
         <p:nvCxnSpPr>
-          <p:cNvPr id="47" name="Connector 46"/>
+          <p:cNvPr id="52" name="Connector 51"/>
           <p:cNvCxnSpPr/>
           <p:nvPr/>
         </p:nvCxnSpPr>
         <p:spPr>
           <a:xfrm>
-            <a:off x="713232" y="5285231"/>
-            <a:ext cx="10442448" cy="0"/>
+            <a:off x="3815399" y="1719072"/>
+            <a:ext cx="0" cy="3236976"/>
           </a:xfrm>
           <a:prstGeom prst="line">
             <a:avLst/>
           </a:prstGeom>
-          <a:ln w="4445">
+          <a:ln w="10160">
             <a:solidFill>
-              <a:srgbClr val="D7D2C8"/>
+              <a:srgbClr val="8A3346"/>
             </a:solidFill>
           </a:ln>
         </p:spPr>
@@ -24997,16 +25198,94 @@
       </p:cxnSp>
       <p:sp>
         <p:nvSpPr>
-          <p:cNvPr id="48" name="Rounded Rectangle 47"/>
+          <p:cNvPr id="53" name="Oval 52"/>
           <p:cNvSpPr/>
           <p:nvPr/>
         </p:nvSpPr>
         <p:spPr>
           <a:xfrm>
-            <a:off x="9626454" y="4965192"/>
-            <a:ext cx="1529225" cy="283464"/>
-          </a:xfrm>
-          <a:prstGeom prst="roundRect">
+            <a:off x="3765107" y="1755648"/>
+            <a:ext cx="100584" cy="100584"/>
+          </a:xfrm>
+          <a:prstGeom prst="ellipse">
+            <a:avLst/>
+          </a:prstGeom>
+          <a:solidFill>
+            <a:srgbClr val="8A3346"/>
+          </a:solidFill>
+          <a:ln>
+            <a:noFill/>
+          </a:ln>
+        </p:spPr>
+        <p:style>
+          <a:lnRef idx="1">
+            <a:schemeClr val="accent1"/>
+          </a:lnRef>
+          <a:fillRef idx="3">
+            <a:schemeClr val="accent1"/>
+          </a:fillRef>
+          <a:effectRef idx="2">
+            <a:schemeClr val="accent1"/>
+          </a:effectRef>
+          <a:fontRef idx="minor">
+            <a:schemeClr val="lt1"/>
+          </a:fontRef>
+        </p:style>
+        <p:txBody>
+          <a:bodyPr rtlCol="0" anchor="ctr"/>
+          <a:lstStyle/>
+          <a:p>
+            <a:pPr algn="ctr"/>
+          </a:p>
+        </p:txBody>
+      </p:sp>
+      <p:cxnSp>
+        <p:nvCxnSpPr>
+          <p:cNvPr id="54" name="Connector 53"/>
+          <p:cNvCxnSpPr/>
+          <p:nvPr/>
+        </p:nvCxnSpPr>
+        <p:spPr>
+          <a:xfrm>
+            <a:off x="7026772" y="1719072"/>
+            <a:ext cx="0" cy="3236976"/>
+          </a:xfrm>
+          <a:prstGeom prst="line">
+            <a:avLst/>
+          </a:prstGeom>
+          <a:ln w="10160">
+            <a:solidFill>
+              <a:srgbClr val="203A57"/>
+            </a:solidFill>
+          </a:ln>
+        </p:spPr>
+        <p:style>
+          <a:lnRef idx="2">
+            <a:schemeClr val="accent1"/>
+          </a:lnRef>
+          <a:fillRef idx="0">
+            <a:schemeClr val="accent1"/>
+          </a:fillRef>
+          <a:effectRef idx="1">
+            <a:schemeClr val="accent1"/>
+          </a:effectRef>
+          <a:fontRef idx="minor">
+            <a:schemeClr val="tx1"/>
+          </a:fontRef>
+        </p:style>
+      </p:cxnSp>
+      <p:sp>
+        <p:nvSpPr>
+          <p:cNvPr id="55" name="Oval 54"/>
+          <p:cNvSpPr/>
+          <p:nvPr/>
+        </p:nvSpPr>
+        <p:spPr>
+          <a:xfrm>
+            <a:off x="6976480" y="1755648"/>
+            <a:ext cx="100584" cy="100584"/>
+          </a:xfrm>
+          <a:prstGeom prst="ellipse">
             <a:avLst/>
           </a:prstGeom>
           <a:solidFill>
@@ -25038,68 +25317,23 @@
           </a:p>
         </p:txBody>
       </p:sp>
-      <p:sp>
-        <p:nvSpPr>
-          <p:cNvPr id="49" name="TextBox 48"/>
-          <p:cNvSpPr txBox="1"/>
-          <p:nvPr/>
-        </p:nvSpPr>
-        <p:spPr>
-          <a:xfrm>
-            <a:off x="9672174" y="5038344"/>
-            <a:ext cx="1437785" cy="109728"/>
-          </a:xfrm>
-          <a:prstGeom prst="rect">
-            <a:avLst/>
-          </a:prstGeom>
-          <a:noFill/>
-        </p:spPr>
-        <p:txBody>
-          <a:bodyPr wrap="square" lIns="45720" rIns="45720" anchor="ctr">
-            <a:spAutoFit/>
-          </a:bodyPr>
-          <a:lstStyle/>
-          <a:p>
-            <a:pPr algn="ctr">
-              <a:lnSpc>
-                <a:spcPct val="100000"/>
-              </a:lnSpc>
-              <a:spcBef>
-                <a:spcPts val="0"/>
-              </a:spcBef>
-              <a:spcAft>
-                <a:spcPts val="0"/>
-              </a:spcAft>
-            </a:pPr>
-            <a:r>
-              <a:rPr sz="620" b="1" i="0">
-                <a:solidFill>
-                  <a:srgbClr val="FFFFFF"/>
-                </a:solidFill>
-                <a:latin typeface="Cascadia Mono"/>
-              </a:rPr>
-              <a:t>PLANNED</a:t>
-            </a:r>
-          </a:p>
-        </p:txBody>
-      </p:sp>
       <p:cxnSp>
         <p:nvCxnSpPr>
-          <p:cNvPr id="50" name="Connector 49"/>
+          <p:cNvPr id="56" name="Connector 55"/>
           <p:cNvCxnSpPr/>
           <p:nvPr/>
         </p:nvCxnSpPr>
         <p:spPr>
           <a:xfrm>
-            <a:off x="3815399" y="1719072"/>
-            <a:ext cx="0" cy="3685032"/>
+            <a:off x="10773373" y="1719072"/>
+            <a:ext cx="0" cy="3236976"/>
           </a:xfrm>
           <a:prstGeom prst="line">
             <a:avLst/>
           </a:prstGeom>
           <a:ln w="10160">
             <a:solidFill>
-              <a:srgbClr val="8A3346"/>
+              <a:srgbClr val="203A57"/>
             </a:solidFill>
           </a:ln>
         </p:spPr>
@@ -25120,13 +25354,91 @@
       </p:cxnSp>
       <p:sp>
         <p:nvSpPr>
-          <p:cNvPr id="51" name="Oval 50"/>
+          <p:cNvPr id="57" name="Oval 56"/>
           <p:cNvSpPr/>
           <p:nvPr/>
         </p:nvSpPr>
         <p:spPr>
           <a:xfrm>
-            <a:off x="3765107" y="1755648"/>
+            <a:off x="10723081" y="1755648"/>
+            <a:ext cx="100584" cy="100584"/>
+          </a:xfrm>
+          <a:prstGeom prst="ellipse">
+            <a:avLst/>
+          </a:prstGeom>
+          <a:solidFill>
+            <a:srgbClr val="203A57"/>
+          </a:solidFill>
+          <a:ln>
+            <a:noFill/>
+          </a:ln>
+        </p:spPr>
+        <p:style>
+          <a:lnRef idx="1">
+            <a:schemeClr val="accent1"/>
+          </a:lnRef>
+          <a:fillRef idx="3">
+            <a:schemeClr val="accent1"/>
+          </a:fillRef>
+          <a:effectRef idx="2">
+            <a:schemeClr val="accent1"/>
+          </a:effectRef>
+          <a:fontRef idx="minor">
+            <a:schemeClr val="lt1"/>
+          </a:fontRef>
+        </p:style>
+        <p:txBody>
+          <a:bodyPr rtlCol="0" anchor="ctr"/>
+          <a:lstStyle/>
+          <a:p>
+            <a:pPr algn="ctr"/>
+          </a:p>
+        </p:txBody>
+      </p:sp>
+      <p:cxnSp>
+        <p:nvCxnSpPr>
+          <p:cNvPr id="58" name="Connector 57"/>
+          <p:cNvCxnSpPr/>
+          <p:nvPr/>
+        </p:nvCxnSpPr>
+        <p:spPr>
+          <a:xfrm>
+            <a:off x="11002757" y="1719072"/>
+            <a:ext cx="0" cy="3236976"/>
+          </a:xfrm>
+          <a:prstGeom prst="line">
+            <a:avLst/>
+          </a:prstGeom>
+          <a:ln w="10160">
+            <a:solidFill>
+              <a:srgbClr val="8A3346"/>
+            </a:solidFill>
+          </a:ln>
+        </p:spPr>
+        <p:style>
+          <a:lnRef idx="2">
+            <a:schemeClr val="accent1"/>
+          </a:lnRef>
+          <a:fillRef idx="0">
+            <a:schemeClr val="accent1"/>
+          </a:fillRef>
+          <a:effectRef idx="1">
+            <a:schemeClr val="accent1"/>
+          </a:effectRef>
+          <a:fontRef idx="minor">
+            <a:schemeClr val="tx1"/>
+          </a:fontRef>
+        </p:style>
+      </p:cxnSp>
+      <p:sp>
+        <p:nvSpPr>
+          <p:cNvPr id="59" name="Oval 58"/>
+          <p:cNvSpPr/>
+          <p:nvPr/>
+        </p:nvSpPr>
+        <p:spPr>
+          <a:xfrm>
+            <a:off x="10952465" y="1755648"/>
             <a:ext cx="100584" cy="100584"/>
           </a:xfrm>
           <a:prstGeom prst="ellipse">
@@ -25161,60 +25473,25 @@
           </a:p>
         </p:txBody>
       </p:sp>
-      <p:cxnSp>
-        <p:nvCxnSpPr>
-          <p:cNvPr id="52" name="Connector 51"/>
-          <p:cNvCxnSpPr/>
-          <p:nvPr/>
-        </p:nvCxnSpPr>
-        <p:spPr>
-          <a:xfrm>
-            <a:off x="7026772" y="1719072"/>
-            <a:ext cx="0" cy="3685032"/>
-          </a:xfrm>
-          <a:prstGeom prst="line">
-            <a:avLst/>
-          </a:prstGeom>
-          <a:ln w="10160">
+      <p:sp>
+        <p:nvSpPr>
+          <p:cNvPr id="60" name="Rectangle 59"/>
+          <p:cNvSpPr/>
+          <p:nvPr/>
+        </p:nvSpPr>
+        <p:spPr>
+          <a:xfrm>
+            <a:off x="10161683" y="4645152"/>
+            <a:ext cx="535228" cy="356616"/>
+          </a:xfrm>
+          <a:prstGeom prst="rect">
+            <a:avLst/>
+          </a:prstGeom>
+          <a:noFill/>
+          <a:ln w="13970">
             <a:solidFill>
-              <a:srgbClr val="203A57"/>
+              <a:srgbClr val="8A3346"/>
             </a:solidFill>
-          </a:ln>
-        </p:spPr>
-        <p:style>
-          <a:lnRef idx="2">
-            <a:schemeClr val="accent1"/>
-          </a:lnRef>
-          <a:fillRef idx="0">
-            <a:schemeClr val="accent1"/>
-          </a:fillRef>
-          <a:effectRef idx="1">
-            <a:schemeClr val="accent1"/>
-          </a:effectRef>
-          <a:fontRef idx="minor">
-            <a:schemeClr val="tx1"/>
-          </a:fontRef>
-        </p:style>
-      </p:cxnSp>
-      <p:sp>
-        <p:nvSpPr>
-          <p:cNvPr id="53" name="Oval 52"/>
-          <p:cNvSpPr/>
-          <p:nvPr/>
-        </p:nvSpPr>
-        <p:spPr>
-          <a:xfrm>
-            <a:off x="6976480" y="1755648"/>
-            <a:ext cx="100584" cy="100584"/>
-          </a:xfrm>
-          <a:prstGeom prst="ellipse">
-            <a:avLst/>
-          </a:prstGeom>
-          <a:solidFill>
-            <a:srgbClr val="203A57"/>
-          </a:solidFill>
-          <a:ln>
-            <a:noFill/>
           </a:ln>
         </p:spPr>
         <p:style>
@@ -25239,214 +25516,15 @@
           </a:p>
         </p:txBody>
       </p:sp>
-      <p:cxnSp>
-        <p:nvCxnSpPr>
-          <p:cNvPr id="54" name="Connector 53"/>
-          <p:cNvCxnSpPr/>
-          <p:nvPr/>
-        </p:nvCxnSpPr>
-        <p:spPr>
-          <a:xfrm>
-            <a:off x="10773373" y="1719072"/>
-            <a:ext cx="0" cy="3685032"/>
-          </a:xfrm>
-          <a:prstGeom prst="line">
-            <a:avLst/>
-          </a:prstGeom>
-          <a:ln w="10160">
-            <a:solidFill>
-              <a:srgbClr val="203A57"/>
-            </a:solidFill>
-          </a:ln>
-        </p:spPr>
-        <p:style>
-          <a:lnRef idx="2">
-            <a:schemeClr val="accent1"/>
-          </a:lnRef>
-          <a:fillRef idx="0">
-            <a:schemeClr val="accent1"/>
-          </a:fillRef>
-          <a:effectRef idx="1">
-            <a:schemeClr val="accent1"/>
-          </a:effectRef>
-          <a:fontRef idx="minor">
-            <a:schemeClr val="tx1"/>
-          </a:fontRef>
-        </p:style>
-      </p:cxnSp>
-      <p:sp>
-        <p:nvSpPr>
-          <p:cNvPr id="55" name="Oval 54"/>
-          <p:cNvSpPr/>
-          <p:nvPr/>
-        </p:nvSpPr>
-        <p:spPr>
-          <a:xfrm>
-            <a:off x="10723081" y="1755648"/>
-            <a:ext cx="100584" cy="100584"/>
-          </a:xfrm>
-          <a:prstGeom prst="ellipse">
-            <a:avLst/>
-          </a:prstGeom>
-          <a:solidFill>
-            <a:srgbClr val="203A57"/>
-          </a:solidFill>
-          <a:ln>
-            <a:noFill/>
-          </a:ln>
-        </p:spPr>
-        <p:style>
-          <a:lnRef idx="1">
-            <a:schemeClr val="accent1"/>
-          </a:lnRef>
-          <a:fillRef idx="3">
-            <a:schemeClr val="accent1"/>
-          </a:fillRef>
-          <a:effectRef idx="2">
-            <a:schemeClr val="accent1"/>
-          </a:effectRef>
-          <a:fontRef idx="minor">
-            <a:schemeClr val="lt1"/>
-          </a:fontRef>
-        </p:style>
-        <p:txBody>
-          <a:bodyPr rtlCol="0" anchor="ctr"/>
-          <a:lstStyle/>
-          <a:p>
-            <a:pPr algn="ctr"/>
-          </a:p>
-        </p:txBody>
-      </p:sp>
-      <p:cxnSp>
-        <p:nvCxnSpPr>
-          <p:cNvPr id="56" name="Connector 55"/>
-          <p:cNvCxnSpPr/>
-          <p:nvPr/>
-        </p:nvCxnSpPr>
-        <p:spPr>
-          <a:xfrm>
-            <a:off x="11002757" y="1719072"/>
-            <a:ext cx="0" cy="3685032"/>
-          </a:xfrm>
-          <a:prstGeom prst="line">
-            <a:avLst/>
-          </a:prstGeom>
-          <a:ln w="10160">
-            <a:solidFill>
-              <a:srgbClr val="8A3346"/>
-            </a:solidFill>
-          </a:ln>
-        </p:spPr>
-        <p:style>
-          <a:lnRef idx="2">
-            <a:schemeClr val="accent1"/>
-          </a:lnRef>
-          <a:fillRef idx="0">
-            <a:schemeClr val="accent1"/>
-          </a:fillRef>
-          <a:effectRef idx="1">
-            <a:schemeClr val="accent1"/>
-          </a:effectRef>
-          <a:fontRef idx="minor">
-            <a:schemeClr val="tx1"/>
-          </a:fontRef>
-        </p:style>
-      </p:cxnSp>
-      <p:sp>
-        <p:nvSpPr>
-          <p:cNvPr id="57" name="Oval 56"/>
-          <p:cNvSpPr/>
-          <p:nvPr/>
-        </p:nvSpPr>
-        <p:spPr>
-          <a:xfrm>
-            <a:off x="10952465" y="1755648"/>
-            <a:ext cx="100584" cy="100584"/>
-          </a:xfrm>
-          <a:prstGeom prst="ellipse">
-            <a:avLst/>
-          </a:prstGeom>
-          <a:solidFill>
-            <a:srgbClr val="8A3346"/>
-          </a:solidFill>
-          <a:ln>
-            <a:noFill/>
-          </a:ln>
-        </p:spPr>
-        <p:style>
-          <a:lnRef idx="1">
-            <a:schemeClr val="accent1"/>
-          </a:lnRef>
-          <a:fillRef idx="3">
-            <a:schemeClr val="accent1"/>
-          </a:fillRef>
-          <a:effectRef idx="2">
-            <a:schemeClr val="accent1"/>
-          </a:effectRef>
-          <a:fontRef idx="minor">
-            <a:schemeClr val="lt1"/>
-          </a:fontRef>
-        </p:style>
-        <p:txBody>
-          <a:bodyPr rtlCol="0" anchor="ctr"/>
-          <a:lstStyle/>
-          <a:p>
-            <a:pPr algn="ctr"/>
-          </a:p>
-        </p:txBody>
-      </p:sp>
-      <p:sp>
-        <p:nvSpPr>
-          <p:cNvPr id="58" name="Rectangle 57"/>
-          <p:cNvSpPr/>
-          <p:nvPr/>
-        </p:nvSpPr>
-        <p:spPr>
-          <a:xfrm>
-            <a:off x="10161683" y="4928616"/>
-            <a:ext cx="535228" cy="356616"/>
-          </a:xfrm>
-          <a:prstGeom prst="rect">
-            <a:avLst/>
-          </a:prstGeom>
-          <a:noFill/>
-          <a:ln w="13970">
-            <a:solidFill>
-              <a:srgbClr val="8A3346"/>
-            </a:solidFill>
-          </a:ln>
-        </p:spPr>
-        <p:style>
-          <a:lnRef idx="1">
-            <a:schemeClr val="accent1"/>
-          </a:lnRef>
-          <a:fillRef idx="3">
-            <a:schemeClr val="accent1"/>
-          </a:fillRef>
-          <a:effectRef idx="2">
-            <a:schemeClr val="accent1"/>
-          </a:effectRef>
-          <a:fontRef idx="minor">
-            <a:schemeClr val="lt1"/>
-          </a:fontRef>
-        </p:style>
-        <p:txBody>
-          <a:bodyPr rtlCol="0" anchor="ctr"/>
-          <a:lstStyle/>
-          <a:p>
-            <a:pPr algn="ctr"/>
-          </a:p>
-        </p:txBody>
-      </p:sp>
-      <p:sp>
-        <p:nvSpPr>
-          <p:cNvPr id="59" name="TextBox 58"/>
-          <p:cNvSpPr txBox="1"/>
-          <p:nvPr/>
-        </p:nvSpPr>
-        <p:spPr>
-          <a:xfrm>
-            <a:off x="10161683" y="5312664"/>
+      <p:sp>
+        <p:nvSpPr>
+          <p:cNvPr id="61" name="TextBox 60"/>
+          <p:cNvSpPr txBox="1"/>
+          <p:nvPr/>
+        </p:nvSpPr>
+        <p:spPr>
+          <a:xfrm>
+            <a:off x="10161683" y="5029200"/>
             <a:ext cx="535228" cy="128016"/>
           </a:xfrm>
           <a:prstGeom prst="rect">
@@ -25485,7 +25563,7 @@
       </p:sp>
       <p:sp>
         <p:nvSpPr>
-          <p:cNvPr id="60" name="Rounded Rectangle 59"/>
+          <p:cNvPr id="62" name="Rounded Rectangle 61"/>
           <p:cNvSpPr/>
           <p:nvPr/>
         </p:nvSpPr>
@@ -25530,7 +25608,7 @@
       </p:sp>
       <p:sp>
         <p:nvSpPr>
-          <p:cNvPr id="61" name="TextBox 60"/>
+          <p:cNvPr id="63" name="TextBox 62"/>
           <p:cNvSpPr txBox="1"/>
           <p:nvPr/>
         </p:nvSpPr>
@@ -25575,7 +25653,7 @@
       </p:sp>
       <p:sp>
         <p:nvSpPr>
-          <p:cNvPr id="62" name="TextBox 61"/>
+          <p:cNvPr id="64" name="TextBox 63"/>
           <p:cNvSpPr txBox="1"/>
           <p:nvPr/>
         </p:nvSpPr>
@@ -25613,14 +25691,14 @@
                 </a:solidFill>
                 <a:latin typeface="Georgia"/>
               </a:rPr>
-              <a:t>G8_C and G8_D are complete. G8_E/E0 is next but not started; all later work remains planned.</a:t>
+              <a:t>G8_C and G8_D are complete. G8_E/E0 is next but not started; G8_F/G and all later work remain planned.</a:t>
             </a:r>
           </a:p>
         </p:txBody>
       </p:sp>
       <p:cxnSp>
         <p:nvCxnSpPr>
-          <p:cNvPr id="63" name="Connector 62"/>
+          <p:cNvPr id="65" name="Connector 64"/>
           <p:cNvCxnSpPr/>
           <p:nvPr/>
         </p:nvCxnSpPr>
@@ -25655,7 +25733,7 @@
       </p:cxnSp>
       <p:sp>
         <p:nvSpPr>
-          <p:cNvPr id="64" name="Rounded Rectangle 63"/>
+          <p:cNvPr id="66" name="Rounded Rectangle 65"/>
           <p:cNvSpPr/>
           <p:nvPr/>
         </p:nvSpPr>
@@ -25698,7 +25776,7 @@
       </p:sp>
       <p:sp>
         <p:nvSpPr>
-          <p:cNvPr id="65" name="TextBox 64"/>
+          <p:cNvPr id="67" name="TextBox 66"/>
           <p:cNvSpPr txBox="1"/>
           <p:nvPr/>
         </p:nvSpPr>
@@ -25743,7 +25821,7 @@
       </p:sp>
       <p:sp>
         <p:nvSpPr>
-          <p:cNvPr id="66" name="TextBox 65"/>
+          <p:cNvPr id="68" name="TextBox 67"/>
           <p:cNvSpPr txBox="1"/>
           <p:nvPr/>
         </p:nvSpPr>
@@ -25788,7 +25866,7 @@
       </p:sp>
       <p:sp>
         <p:nvSpPr>
-          <p:cNvPr id="67" name="TextBox 66"/>
+          <p:cNvPr id="69" name="TextBox 68"/>
           <p:cNvSpPr txBox="1"/>
           <p:nvPr/>
         </p:nvSpPr>

</xml_diff>